<commit_message>
skh-pt: 10-page deck now cover + 9 content slides; keep figure transparency on gradient panels
Co-Authored-By: Claude Opus 5.5 <noreply@anthropic.com>
Claude-Session: https://claude.ai/code/session_01D2YY6No1o1YF3BX8eJSF6k
</commit_message>
<xml_diff>
--- a/skh-pt/pptx/deck10.pptx
+++ b/skh-pt/pptx/deck10.pptx
@@ -511,7 +511,7 @@
           <a:p>
             <a:r>
               <a:rPr lang="en-US" dirty="0"/>
-              <a:t>안녕하세요, 오늘 발표할 연구는 「평면도와 입면도 객체 인식 및 정보 통합을 통한 3D BIM 자동 생성 연구」입니다. 평면도와 입면도 이미지만으로 높이까지 갖춘 3D BIM 모델을 자동으로 만드는 연구이고, Automation in Construction 187권에 2026년 게재되었습니다. 발표는 다섯 장으로 구성했습니다. 1장과 2장은 '문제' 부분으로, 왜 이 연구가 필요한지, 그리고 기존 연구로는 왜 안 되는지와 그래서 무엇을 목표로 했는지 말씀드립니다. 3장과 4장은 '해결' 부분으로, 어떻게 해결했는지와 얼마나 잘 됐고 어떤 의미가 있는지를 보여 드립니다. 마지막 5장에서는 이 연구가 SK하이닉스 Utility 기술(건축, BIM/5D) 직무에서 왜 중요한지, 그 의미를 말씀드리겠습니다.</a:t>
+              <a:t>안녕하세요, 오늘 발표할 연구는 「평면도와 입면도 객체 인식 및 정보 통합을 통한 3D BIM 자동 생성 연구」입니다. 평면도와 입면도 이미지만으로 높이까지 갖춘 3D BIM 모델을 자동으로 만드는 연구이고, Automation in Construction 187권에 2026년 게재되었습니다. 오른쪽 그림처럼 2D 도면 묶음을 넣으면 3D BIM 모델이 자동으로 생성되는 흐름입니다. Utility 기술(건축, BIM/5D) 직무에 지원한 ○○○입니다. 발표는 다섯 장으로 구성했습니다. 1장과 2장에서 문제를, 3장과 4장에서 해결 방법과 결과를, 5장에서 SK하이닉스 직무에서의 의미를 말씀드리겠습니다.</a:t>
             </a:r>
             <a:endParaRPr lang="en-US" dirty="0"/>
           </a:p>
@@ -1678,22 +1678,60 @@
       </p:grpSpPr>
       <p:sp>
         <p:nvSpPr>
-          <p:cNvPr id="3" name="sep"/>
-          <p:cNvSpPr/>
-          <p:nvPr/>
-        </p:nvSpPr>
-        <p:spPr>
-          <a:xfrm>
-            <a:off x="1595934" y="425450"/>
-            <a:ext cx="6350" cy="101600"/>
+          <p:cNvPr id="3" name="body::before"/>
+          <p:cNvSpPr/>
+          <p:nvPr/>
+        </p:nvSpPr>
+        <p:spPr>
+          <a:xfrm>
+            <a:off x="7112000" y="0"/>
+            <a:ext cx="5080000" cy="6858000"/>
+          </a:xfrm>
+          <a:prstGeom prst="rect">
+            <a:avLst/>
+          </a:prstGeom>
+          <a:gradFill rotWithShape="1">
+            <a:gsLst>
+              <a:gs pos="0">
+                <a:srgbClr val="F5F7FA"/>
+              </a:gs>
+              <a:gs pos="100000">
+                <a:srgbClr val="E6ECF4"/>
+              </a:gs>
+            </a:gsLst>
+            <a:lin ang="5400000" scaled="0"/>
+          </a:gradFill>
+          <a:ln>
+            <a:noFill/>
+          </a:ln>
+        </p:spPr>
+        <p:txBody>
+          <a:bodyPr rtlCol="0" anchor="ctr"/>
+          <a:lstStyle/>
+          <a:p>
+            <a:pPr algn="ctr"/>
+            <a:endParaRPr lang="ko-KR" dirty="0"/>
+          </a:p>
+        </p:txBody>
+      </p:sp>
+      <p:sp>
+        <p:nvSpPr>
+          <p:cNvPr id="4" name="i"/>
+          <p:cNvSpPr/>
+          <p:nvPr/>
+        </p:nvSpPr>
+        <p:spPr>
+          <a:xfrm>
+            <a:off x="609600" y="615950"/>
+            <a:ext cx="177800" cy="25400"/>
           </a:xfrm>
           <a:prstGeom prst="roundRect">
             <a:avLst>
-              <a:gd name="adj" fmla="val 0"/>
+              <a:gd name="adj" fmla="val 50000"/>
             </a:avLst>
           </a:prstGeom>
           <a:solidFill>
-            <a:srgbClr val="C8CFD8"/>
+            <a:srgbClr val="EA002C"/>
           </a:solidFill>
           <a:ln>
             <a:noFill/>
@@ -1710,18 +1748,519 @@
       </p:sp>
       <p:sp>
         <p:nvSpPr>
-          <p:cNvPr id="4" name="gh c1::after"/>
-          <p:cNvSpPr/>
-          <p:nvPr/>
-        </p:nvSpPr>
-        <p:spPr>
-          <a:xfrm>
-            <a:off x="968573" y="2067024"/>
-            <a:ext cx="3730427" cy="12700"/>
+          <p:cNvPr id="5" name="s1-pub"/>
+          <p:cNvSpPr/>
+          <p:nvPr/>
+        </p:nvSpPr>
+        <p:spPr>
+          <a:xfrm>
+            <a:off x="612775" y="4070152"/>
+            <a:ext cx="3089771" cy="298450"/>
           </a:xfrm>
           <a:prstGeom prst="roundRect">
             <a:avLst>
               <a:gd name="adj" fmla="val 50000"/>
+            </a:avLst>
+          </a:prstGeom>
+          <a:solidFill>
+            <a:srgbClr val="FFFFFF"/>
+          </a:solidFill>
+          <a:ln w="6350">
+            <a:solidFill>
+              <a:srgbClr val="C8CFD8"/>
+            </a:solidFill>
+            <a:miter lim="800000"/>
+          </a:ln>
+        </p:spPr>
+        <p:txBody>
+          <a:bodyPr rtlCol="0" anchor="ctr"/>
+          <a:lstStyle/>
+          <a:p>
+            <a:pPr algn="ctr"/>
+            <a:endParaRPr lang="ko-KR" dirty="0"/>
+          </a:p>
+        </p:txBody>
+      </p:sp>
+      <p:sp>
+        <p:nvSpPr>
+          <p:cNvPr id="6" name="i"/>
+          <p:cNvSpPr/>
+          <p:nvPr/>
+        </p:nvSpPr>
+        <p:spPr>
+          <a:xfrm>
+            <a:off x="742950" y="4187627"/>
+            <a:ext cx="63500" cy="63500"/>
+          </a:xfrm>
+          <a:prstGeom prst="ellipse">
+            <a:avLst/>
+          </a:prstGeom>
+          <a:solidFill>
+            <a:srgbClr val="EA002C"/>
+          </a:solidFill>
+          <a:ln>
+            <a:noFill/>
+          </a:ln>
+        </p:spPr>
+        <p:txBody>
+          <a:bodyPr rtlCol="0" anchor="ctr"/>
+          <a:lstStyle/>
+          <a:p>
+            <a:pPr algn="ctr"/>
+            <a:endParaRPr lang="ko-KR" dirty="0"/>
+          </a:p>
+        </p:txBody>
+      </p:sp>
+      <p:sp>
+        <p:nvSpPr>
+          <p:cNvPr id="7" name="s1-meta 선"/>
+          <p:cNvSpPr/>
+          <p:nvPr/>
+        </p:nvSpPr>
+        <p:spPr>
+          <a:xfrm>
+            <a:off x="612775" y="5781080"/>
+            <a:ext cx="5734050" cy="1"/>
+          </a:xfrm>
+          <a:custGeom>
+            <a:avLst/>
+            <a:gdLst/>
+            <a:ahLst/>
+            <a:cxnLst/>
+            <a:rect l="0" t="0" r="r" b="b"/>
+            <a:pathLst>
+              <a:path w="5734050" h="1" fill="none">
+                <a:moveTo>
+                  <a:pt x="0" y="0"/>
+                </a:moveTo>
+                <a:lnTo>
+                  <a:pt x="5734050" y="0"/>
+                </a:lnTo>
+              </a:path>
+            </a:pathLst>
+          </a:custGeom>
+          <a:noFill/>
+          <a:ln w="6350">
+            <a:solidFill>
+              <a:srgbClr val="E1E5EB"/>
+            </a:solidFill>
+            <a:round/>
+          </a:ln>
+        </p:spPr>
+        <p:txBody>
+          <a:bodyPr rtlCol="0" anchor="ctr"/>
+          <a:lstStyle/>
+          <a:p>
+            <a:pPr algn="ctr"/>
+            <a:endParaRPr lang="ko-KR" dirty="0"/>
+          </a:p>
+        </p:txBody>
+      </p:sp>
+      <p:sp>
+        <p:nvSpPr>
+          <p:cNvPr id="8" name="div 선"/>
+          <p:cNvSpPr/>
+          <p:nvPr/>
+        </p:nvSpPr>
+        <p:spPr>
+          <a:xfrm>
+            <a:off x="2430661" y="5939830"/>
+            <a:ext cx="1" cy="381496"/>
+          </a:xfrm>
+          <a:custGeom>
+            <a:avLst/>
+            <a:gdLst/>
+            <a:ahLst/>
+            <a:cxnLst/>
+            <a:rect l="0" t="0" r="r" b="b"/>
+            <a:pathLst>
+              <a:path w="1" h="381496" fill="none">
+                <a:moveTo>
+                  <a:pt x="0" y="381496"/>
+                </a:moveTo>
+                <a:lnTo>
+                  <a:pt x="0" y="0"/>
+                </a:lnTo>
+              </a:path>
+            </a:pathLst>
+          </a:custGeom>
+          <a:noFill/>
+          <a:ln w="6350">
+            <a:solidFill>
+              <a:srgbClr val="E1E5EB"/>
+            </a:solidFill>
+            <a:round/>
+          </a:ln>
+        </p:spPr>
+        <p:txBody>
+          <a:bodyPr rtlCol="0" anchor="ctr"/>
+          <a:lstStyle/>
+          <a:p>
+            <a:pPr algn="ctr"/>
+            <a:endParaRPr lang="ko-KR" dirty="0"/>
+          </a:p>
+        </p:txBody>
+      </p:sp>
+      <p:sp>
+        <p:nvSpPr>
+          <p:cNvPr id="9" name="div 선"/>
+          <p:cNvSpPr/>
+          <p:nvPr/>
+        </p:nvSpPr>
+        <p:spPr>
+          <a:xfrm>
+            <a:off x="3749278" y="5939830"/>
+            <a:ext cx="1" cy="381496"/>
+          </a:xfrm>
+          <a:custGeom>
+            <a:avLst/>
+            <a:gdLst/>
+            <a:ahLst/>
+            <a:cxnLst/>
+            <a:rect l="0" t="0" r="r" b="b"/>
+            <a:pathLst>
+              <a:path w="1" h="381496" fill="none">
+                <a:moveTo>
+                  <a:pt x="0" y="381496"/>
+                </a:moveTo>
+                <a:lnTo>
+                  <a:pt x="0" y="0"/>
+                </a:lnTo>
+              </a:path>
+            </a:pathLst>
+          </a:custGeom>
+          <a:noFill/>
+          <a:ln w="6350">
+            <a:solidFill>
+              <a:srgbClr val="E1E5EB"/>
+            </a:solidFill>
+            <a:round/>
+          </a:ln>
+        </p:spPr>
+        <p:txBody>
+          <a:bodyPr rtlCol="0" anchor="ctr"/>
+          <a:lstStyle/>
+          <a:p>
+            <a:pPr algn="ctr"/>
+            <a:endParaRPr lang="ko-KR" dirty="0"/>
+          </a:p>
+        </p:txBody>
+      </p:sp>
+      <p:pic>
+        <p:nvPicPr>
+          <p:cNvPr id="10" name="s1-logo" descr="s1-logo">    </p:cNvPr>
+          <p:cNvPicPr>
+            <a:picLocks noChangeAspect="1"/>
+          </p:cNvPicPr>
+          <p:nvPr/>
+        </p:nvPicPr>
+        <p:blipFill>
+          <a:blip r:embed="rId1"/>
+          <a:stretch>
+            <a:fillRect/>
+          </a:stretch>
+        </p:blipFill>
+        <p:spPr>
+          <a:xfrm>
+            <a:off x="10733617" y="412750"/>
+            <a:ext cx="802217" cy="423333"/>
+          </a:xfrm>
+          <a:prstGeom prst="rect">
+            <a:avLst/>
+          </a:prstGeom>
+        </p:spPr>
+      </p:pic>
+      <p:pic>
+        <p:nvPicPr>
+          <p:cNvPr id="11" name="img" descr="img">    </p:cNvPr>
+          <p:cNvPicPr>
+            <a:picLocks noChangeAspect="1"/>
+          </p:cNvPicPr>
+          <p:nvPr/>
+        </p:nvPicPr>
+        <p:blipFill>
+          <a:blip r:embed="rId2"/>
+          <a:stretch>
+            <a:fillRect/>
+          </a:stretch>
+        </p:blipFill>
+        <p:spPr>
+          <a:xfrm>
+            <a:off x="7431617" y="548217"/>
+            <a:ext cx="2207683" cy="2205567"/>
+          </a:xfrm>
+          <a:prstGeom prst="rect">
+            <a:avLst/>
+          </a:prstGeom>
+        </p:spPr>
+      </p:pic>
+      <p:sp>
+        <p:nvSpPr>
+          <p:cNvPr id="12" name="s1-shadow"/>
+          <p:cNvSpPr/>
+          <p:nvPr/>
+        </p:nvSpPr>
+        <p:spPr>
+          <a:xfrm>
+            <a:off x="8229600" y="5791200"/>
+            <a:ext cx="3352800" cy="558800"/>
+          </a:xfrm>
+          <a:prstGeom prst="ellipse">
+            <a:avLst/>
+          </a:prstGeom>
+          <a:gradFill rotWithShape="1">
+            <a:gsLst>
+              <a:gs pos="0">
+                <a:srgbClr val="102A4C">
+                  <a:alpha val="16000"/>
+                </a:srgbClr>
+              </a:gs>
+              <a:gs pos="100000">
+                <a:srgbClr val="102A4C">
+                  <a:alpha val="0"/>
+                </a:srgbClr>
+              </a:gs>
+            </a:gsLst>
+            <a:path path="circle">
+              <a:fillToRect l="50000" t="50000" r="50000" b="50000"/>
+            </a:path>
+          </a:gradFill>
+          <a:ln>
+            <a:noFill/>
+          </a:ln>
+        </p:spPr>
+        <p:txBody>
+          <a:bodyPr rtlCol="0" anchor="ctr"/>
+          <a:lstStyle/>
+          <a:p>
+            <a:pPr algn="ctr"/>
+            <a:endParaRPr lang="ko-KR" dirty="0"/>
+          </a:p>
+        </p:txBody>
+      </p:sp>
+      <p:pic>
+        <p:nvPicPr>
+          <p:cNvPr id="13" name="img" descr="img">    </p:cNvPr>
+          <p:cNvPicPr>
+            <a:picLocks noChangeAspect="1"/>
+          </p:cNvPicPr>
+          <p:nvPr/>
+        </p:nvPicPr>
+        <p:blipFill>
+          <a:blip r:embed="rId3"/>
+          <a:stretch>
+            <a:fillRect/>
+          </a:stretch>
+        </p:blipFill>
+        <p:spPr>
+          <a:xfrm>
+            <a:off x="8123767" y="3007783"/>
+            <a:ext cx="3437467" cy="3308350"/>
+          </a:xfrm>
+          <a:prstGeom prst="rect">
+            <a:avLst/>
+          </a:prstGeom>
+        </p:spPr>
+      </p:pic>
+      <p:sp>
+        <p:nvSpPr>
+          <p:cNvPr id="14" name="s1-link path"/>
+          <p:cNvSpPr/>
+          <p:nvPr/>
+        </p:nvSpPr>
+        <p:spPr>
+          <a:xfrm>
+            <a:off x="9702800" y="571500"/>
+            <a:ext cx="50800" cy="2159000"/>
+          </a:xfrm>
+          <a:custGeom>
+            <a:avLst/>
+            <a:gdLst/>
+            <a:ahLst/>
+            <a:cxnLst/>
+            <a:rect l="0" t="0" r="r" b="b"/>
+            <a:pathLst>
+              <a:path w="50800" h="2159000" fill="none">
+                <a:moveTo>
+                  <a:pt x="0" y="0"/>
+                </a:moveTo>
+                <a:lnTo>
+                  <a:pt x="50800" y="0"/>
+                </a:lnTo>
+                <a:lnTo>
+                  <a:pt x="50800" y="2159000"/>
+                </a:lnTo>
+                <a:lnTo>
+                  <a:pt x="0" y="2159000"/>
+                </a:lnTo>
+              </a:path>
+            </a:pathLst>
+          </a:custGeom>
+          <a:noFill/>
+          <a:ln w="12700" cap="rnd">
+            <a:solidFill>
+              <a:srgbClr val="2B4A78"/>
+            </a:solidFill>
+            <a:round/>
+          </a:ln>
+        </p:spPr>
+        <p:txBody>
+          <a:bodyPr rtlCol="0" anchor="ctr"/>
+          <a:lstStyle/>
+          <a:p>
+            <a:pPr algn="ctr"/>
+            <a:endParaRPr lang="ko-KR" dirty="0"/>
+          </a:p>
+        </p:txBody>
+      </p:sp>
+      <p:sp>
+        <p:nvSpPr>
+          <p:cNvPr id="15" name="s1-link path"/>
+          <p:cNvSpPr/>
+          <p:nvPr/>
+        </p:nvSpPr>
+        <p:spPr>
+          <a:xfrm>
+            <a:off x="9753600" y="1651000"/>
+            <a:ext cx="1168400" cy="1841500"/>
+          </a:xfrm>
+          <a:custGeom>
+            <a:avLst/>
+            <a:gdLst/>
+            <a:ahLst/>
+            <a:cxnLst/>
+            <a:rect l="0" t="0" r="r" b="b"/>
+            <a:pathLst>
+              <a:path w="1168400" h="1841500" fill="none">
+                <a:moveTo>
+                  <a:pt x="0" y="0"/>
+                </a:moveTo>
+                <a:lnTo>
+                  <a:pt x="1168400" y="0"/>
+                </a:lnTo>
+                <a:lnTo>
+                  <a:pt x="1168400" y="1841500"/>
+                </a:lnTo>
+              </a:path>
+            </a:pathLst>
+          </a:custGeom>
+          <a:noFill/>
+          <a:ln w="12700" cap="rnd">
+            <a:solidFill>
+              <a:srgbClr val="2B4A78"/>
+            </a:solidFill>
+            <a:custDash>
+              <a:ds d="300000" sp="300000"/>
+            </a:custDash>
+            <a:miter lim="800000"/>
+          </a:ln>
+        </p:spPr>
+        <p:txBody>
+          <a:bodyPr rtlCol="0" anchor="ctr"/>
+          <a:lstStyle/>
+          <a:p>
+            <a:pPr algn="ctr"/>
+            <a:endParaRPr lang="ko-KR" dirty="0"/>
+          </a:p>
+        </p:txBody>
+      </p:sp>
+      <p:sp>
+        <p:nvSpPr>
+          <p:cNvPr id="16" name="s1-link path"/>
+          <p:cNvSpPr/>
+          <p:nvPr/>
+        </p:nvSpPr>
+        <p:spPr>
+          <a:xfrm>
+            <a:off x="10864850" y="3448050"/>
+            <a:ext cx="114300" cy="69850"/>
+          </a:xfrm>
+          <a:custGeom>
+            <a:avLst/>
+            <a:gdLst/>
+            <a:ahLst/>
+            <a:cxnLst/>
+            <a:rect l="0" t="0" r="r" b="b"/>
+            <a:pathLst>
+              <a:path w="114300" h="69850" fill="none">
+                <a:moveTo>
+                  <a:pt x="0" y="0"/>
+                </a:moveTo>
+                <a:lnTo>
+                  <a:pt x="57150" y="69850"/>
+                </a:lnTo>
+                <a:lnTo>
+                  <a:pt x="114300" y="0"/>
+                </a:lnTo>
+              </a:path>
+            </a:pathLst>
+          </a:custGeom>
+          <a:noFill/>
+          <a:ln w="12700" cap="rnd">
+            <a:solidFill>
+              <a:srgbClr val="2B4A78"/>
+            </a:solidFill>
+            <a:round/>
+          </a:ln>
+        </p:spPr>
+        <p:txBody>
+          <a:bodyPr rtlCol="0" anchor="ctr"/>
+          <a:lstStyle/>
+          <a:p>
+            <a:pPr algn="ctr"/>
+            <a:endParaRPr lang="ko-KR" dirty="0"/>
+          </a:p>
+        </p:txBody>
+      </p:sp>
+      <p:sp>
+        <p:nvSpPr>
+          <p:cNvPr id="17" name="s1-auto"/>
+          <p:cNvSpPr/>
+          <p:nvPr/>
+        </p:nvSpPr>
+        <p:spPr>
+          <a:xfrm>
+            <a:off x="10062170" y="1546225"/>
+            <a:ext cx="551259" cy="209550"/>
+          </a:xfrm>
+          <a:prstGeom prst="roundRect">
+            <a:avLst>
+              <a:gd name="adj" fmla="val 50000"/>
+            </a:avLst>
+          </a:prstGeom>
+          <a:solidFill>
+            <a:srgbClr val="FFFFFF"/>
+          </a:solidFill>
+          <a:ln w="6350">
+            <a:solidFill>
+              <a:srgbClr val="C8CFD8"/>
+            </a:solidFill>
+            <a:miter lim="800000"/>
+          </a:ln>
+        </p:spPr>
+        <p:txBody>
+          <a:bodyPr rtlCol="0" anchor="ctr"/>
+          <a:lstStyle/>
+          <a:p>
+            <a:pPr algn="ctr"/>
+            <a:endParaRPr lang="ko-KR" dirty="0"/>
+          </a:p>
+        </p:txBody>
+      </p:sp>
+      <p:sp>
+        <p:nvSpPr>
+          <p:cNvPr id="18" name="b"/>
+          <p:cNvSpPr/>
+          <p:nvPr/>
+        </p:nvSpPr>
+        <p:spPr>
+          <a:xfrm>
+            <a:off x="7416800" y="2895600"/>
+            <a:ext cx="222945" cy="165100"/>
+          </a:xfrm>
+          <a:prstGeom prst="roundRect">
+            <a:avLst>
+              <a:gd name="adj" fmla="val 23077"/>
             </a:avLst>
           </a:prstGeom>
           <a:solidFill>
@@ -1742,66 +2281,18 @@
       </p:sp>
       <p:sp>
         <p:nvSpPr>
-          <p:cNvPr id="5" name="svg path"/>
-          <p:cNvSpPr/>
-          <p:nvPr/>
-        </p:nvSpPr>
-        <p:spPr>
-          <a:xfrm>
-            <a:off x="4876800" y="2028924"/>
-            <a:ext cx="44450" cy="88900"/>
-          </a:xfrm>
-          <a:custGeom>
-            <a:avLst/>
-            <a:gdLst/>
-            <a:ahLst/>
-            <a:cxnLst/>
-            <a:rect l="0" t="0" r="r" b="b"/>
-            <a:pathLst>
-              <a:path w="44450" h="88900" fill="none">
-                <a:moveTo>
-                  <a:pt x="0" y="0"/>
-                </a:moveTo>
-                <a:lnTo>
-                  <a:pt x="44450" y="44450"/>
-                </a:lnTo>
-                <a:lnTo>
-                  <a:pt x="0" y="88900"/>
-                </a:lnTo>
-              </a:path>
-            </a:pathLst>
-          </a:custGeom>
-          <a:noFill/>
-          <a:ln w="15875" cap="rnd">
-            <a:solidFill>
-              <a:srgbClr val="102A4C"/>
-            </a:solidFill>
-            <a:round/>
-          </a:ln>
-        </p:spPr>
-        <p:txBody>
-          <a:bodyPr rtlCol="0" anchor="ctr"/>
-          <a:lstStyle/>
-          <a:p>
-            <a:pPr algn="ctr"/>
-            <a:endParaRPr lang="ko-KR" dirty="0"/>
-          </a:p>
-        </p:txBody>
-      </p:sp>
-      <p:sp>
-        <p:nvSpPr>
-          <p:cNvPr id="6" name="gh c2::after"/>
-          <p:cNvSpPr/>
-          <p:nvPr/>
-        </p:nvSpPr>
-        <p:spPr>
-          <a:xfrm>
-            <a:off x="5464373" y="2067024"/>
-            <a:ext cx="3730427" cy="12700"/>
+          <p:cNvPr id="19" name="b"/>
+          <p:cNvSpPr/>
+          <p:nvPr/>
+        </p:nvSpPr>
+        <p:spPr>
+          <a:xfrm>
+            <a:off x="7416800" y="6108700"/>
+            <a:ext cx="225425" cy="165100"/>
           </a:xfrm>
           <a:prstGeom prst="roundRect">
             <a:avLst>
-              <a:gd name="adj" fmla="val 50000"/>
+              <a:gd name="adj" fmla="val 23077"/>
             </a:avLst>
           </a:prstGeom>
           <a:solidFill>
@@ -1822,1475 +2313,14 @@
       </p:sp>
       <p:sp>
         <p:nvSpPr>
-          <p:cNvPr id="7" name="svg path"/>
-          <p:cNvSpPr/>
-          <p:nvPr/>
-        </p:nvSpPr>
-        <p:spPr>
-          <a:xfrm>
-            <a:off x="9372600" y="2028924"/>
-            <a:ext cx="44450" cy="88900"/>
-          </a:xfrm>
-          <a:custGeom>
-            <a:avLst/>
-            <a:gdLst/>
-            <a:ahLst/>
-            <a:cxnLst/>
-            <a:rect l="0" t="0" r="r" b="b"/>
-            <a:pathLst>
-              <a:path w="44450" h="88900" fill="none">
-                <a:moveTo>
-                  <a:pt x="0" y="0"/>
-                </a:moveTo>
-                <a:lnTo>
-                  <a:pt x="44450" y="44450"/>
-                </a:lnTo>
-                <a:lnTo>
-                  <a:pt x="0" y="88900"/>
-                </a:lnTo>
-              </a:path>
-            </a:pathLst>
-          </a:custGeom>
-          <a:noFill/>
-          <a:ln w="15875" cap="rnd">
-            <a:solidFill>
-              <a:srgbClr val="102A4C"/>
-            </a:solidFill>
-            <a:round/>
-          </a:ln>
-        </p:spPr>
-        <p:txBody>
-          <a:bodyPr rtlCol="0" anchor="ctr"/>
-          <a:lstStyle/>
-          <a:p>
-            <a:pPr algn="ctr"/>
-            <a:endParaRPr lang="ko-KR" dirty="0"/>
-          </a:p>
-        </p:txBody>
-      </p:sp>
-      <p:sp>
-        <p:nvSpPr>
-          <p:cNvPr id="8" name="gh c3::after"/>
-          <p:cNvSpPr/>
-          <p:nvPr/>
-        </p:nvSpPr>
-        <p:spPr>
-          <a:xfrm>
-            <a:off x="9960173" y="2067024"/>
-            <a:ext cx="1622227" cy="12700"/>
-          </a:xfrm>
-          <a:prstGeom prst="roundRect">
-            <a:avLst>
-              <a:gd name="adj" fmla="val 50000"/>
-            </a:avLst>
-          </a:prstGeom>
-          <a:solidFill>
-            <a:srgbClr val="102A4C"/>
-          </a:solidFill>
-          <a:ln>
-            <a:noFill/>
-          </a:ln>
-        </p:spPr>
-        <p:txBody>
-          <a:bodyPr rtlCol="0" anchor="ctr"/>
-          <a:lstStyle/>
-          <a:p>
-            <a:pPr algn="ctr"/>
-            <a:endParaRPr lang="ko-KR" dirty="0"/>
-          </a:p>
-        </p:txBody>
-      </p:sp>
-      <p:sp>
-        <p:nvSpPr>
-          <p:cNvPr id="9" name="ch k1"/>
-          <p:cNvSpPr/>
-          <p:nvPr/>
-        </p:nvSpPr>
-        <p:spPr>
-          <a:xfrm>
-            <a:off x="609600" y="2378174"/>
-            <a:ext cx="1981200" cy="2946400"/>
-          </a:xfrm>
-          <a:prstGeom prst="roundRect">
-            <a:avLst>
-              <a:gd name="adj" fmla="val 6410"/>
-            </a:avLst>
-          </a:prstGeom>
-          <a:solidFill>
-            <a:srgbClr val="F3F5F8"/>
-          </a:solidFill>
-          <a:ln>
-            <a:noFill/>
-          </a:ln>
-        </p:spPr>
-        <p:txBody>
-          <a:bodyPr rtlCol="0" anchor="ctr"/>
-          <a:lstStyle/>
-          <a:p>
-            <a:pPr algn="ctr"/>
-            <a:endParaRPr lang="ko-KR" dirty="0"/>
-          </a:p>
-        </p:txBody>
-      </p:sp>
-      <p:sp>
-        <p:nvSpPr>
-          <p:cNvPr id="10" name="svg circle"/>
-          <p:cNvSpPr/>
-          <p:nvPr/>
-        </p:nvSpPr>
-        <p:spPr>
-          <a:xfrm>
-            <a:off x="2203450" y="2702024"/>
-            <a:ext cx="127000" cy="127000"/>
-          </a:xfrm>
-          <a:prstGeom prst="ellipse">
-            <a:avLst/>
-          </a:prstGeom>
-          <a:noFill/>
-          <a:ln w="12700" cap="rnd">
-            <a:solidFill>
-              <a:srgbClr val="2B4A78"/>
-            </a:solidFill>
-            <a:round/>
-          </a:ln>
-        </p:spPr>
-        <p:txBody>
-          <a:bodyPr rtlCol="0" anchor="ctr"/>
-          <a:lstStyle/>
-          <a:p>
-            <a:pPr algn="ctr"/>
-            <a:endParaRPr lang="ko-KR" dirty="0"/>
-          </a:p>
-        </p:txBody>
-      </p:sp>
-      <p:sp>
-        <p:nvSpPr>
-          <p:cNvPr id="11" name="svg path"/>
-          <p:cNvSpPr/>
-          <p:nvPr/>
-        </p:nvSpPr>
-        <p:spPr>
-          <a:xfrm>
-            <a:off x="2314575" y="2813149"/>
-            <a:ext cx="60325" cy="60325"/>
-          </a:xfrm>
-          <a:custGeom>
-            <a:avLst/>
-            <a:gdLst/>
-            <a:ahLst/>
-            <a:cxnLst/>
-            <a:rect l="0" t="0" r="r" b="b"/>
-            <a:pathLst>
-              <a:path w="60325" h="60325" fill="none">
-                <a:moveTo>
-                  <a:pt x="0" y="0"/>
-                </a:moveTo>
-                <a:lnTo>
-                  <a:pt x="60325" y="60325"/>
-                </a:lnTo>
-              </a:path>
-            </a:pathLst>
-          </a:custGeom>
-          <a:noFill/>
-          <a:ln w="12700" cap="rnd">
-            <a:solidFill>
-              <a:srgbClr val="2B4A78"/>
-            </a:solidFill>
-            <a:round/>
-          </a:ln>
-        </p:spPr>
-        <p:txBody>
-          <a:bodyPr rtlCol="0" anchor="ctr"/>
-          <a:lstStyle/>
-          <a:p>
-            <a:pPr algn="ctr"/>
-            <a:endParaRPr lang="ko-KR" dirty="0"/>
-          </a:p>
-        </p:txBody>
-      </p:sp>
-      <p:sp>
-        <p:nvSpPr>
-          <p:cNvPr id="12" name="svg path"/>
-          <p:cNvSpPr/>
-          <p:nvPr/>
-        </p:nvSpPr>
-        <p:spPr>
-          <a:xfrm>
-            <a:off x="2241550" y="2740124"/>
-            <a:ext cx="50800" cy="50800"/>
-          </a:xfrm>
-          <a:custGeom>
-            <a:avLst/>
-            <a:gdLst/>
-            <a:ahLst/>
-            <a:cxnLst/>
-            <a:rect l="0" t="0" r="r" b="b"/>
-            <a:pathLst>
-              <a:path w="50800" h="50800" fill="none">
-                <a:moveTo>
-                  <a:pt x="0" y="25400"/>
-                </a:moveTo>
-                <a:lnTo>
-                  <a:pt x="50800" y="25400"/>
-                </a:lnTo>
-                <a:moveTo>
-                  <a:pt x="25400" y="0"/>
-                </a:moveTo>
-                <a:lnTo>
-                  <a:pt x="25400" y="50800"/>
-                </a:lnTo>
-              </a:path>
-            </a:pathLst>
-          </a:custGeom>
-          <a:noFill/>
-          <a:ln w="12700" cap="rnd">
-            <a:solidFill>
-              <a:srgbClr val="2B4A78"/>
-            </a:solidFill>
-            <a:round/>
-          </a:ln>
-        </p:spPr>
-        <p:txBody>
-          <a:bodyPr rtlCol="0" anchor="ctr"/>
-          <a:lstStyle/>
-          <a:p>
-            <a:pPr algn="ctr"/>
-            <a:endParaRPr lang="ko-KR" dirty="0"/>
-          </a:p>
-        </p:txBody>
-      </p:sp>
-      <p:sp>
-        <p:nvSpPr>
-          <p:cNvPr id="13" name="bar"/>
-          <p:cNvSpPr/>
-          <p:nvPr/>
-        </p:nvSpPr>
-        <p:spPr>
-          <a:xfrm>
-            <a:off x="812800" y="3267174"/>
-            <a:ext cx="203200" cy="19050"/>
-          </a:xfrm>
-          <a:prstGeom prst="roundRect">
-            <a:avLst>
-              <a:gd name="adj" fmla="val 50000"/>
-            </a:avLst>
-          </a:prstGeom>
-          <a:solidFill>
-            <a:srgbClr val="102A4C"/>
-          </a:solidFill>
-          <a:ln>
-            <a:noFill/>
-          </a:ln>
-        </p:spPr>
-        <p:txBody>
-          <a:bodyPr rtlCol="0" anchor="ctr"/>
-          <a:lstStyle/>
-          <a:p>
-            <a:pPr algn="ctr"/>
-            <a:endParaRPr lang="ko-KR" dirty="0"/>
-          </a:p>
-        </p:txBody>
-      </p:sp>
-      <p:sp>
-        <p:nvSpPr>
-          <p:cNvPr id="14" name="q"/>
-          <p:cNvSpPr/>
-          <p:nvPr/>
-        </p:nvSpPr>
-        <p:spPr>
-          <a:xfrm>
-            <a:off x="609600" y="4410174"/>
-            <a:ext cx="1981200" cy="914400"/>
-          </a:xfrm>
-          <a:custGeom>
-            <a:avLst/>
-            <a:gdLst/>
-            <a:ahLst/>
-            <a:cxnLst/>
-            <a:rect l="0" t="0" r="r" b="b"/>
-            <a:pathLst>
-              <a:path w="1981200" h="914400" stroke="0">
-                <a:moveTo>
-                  <a:pt x="0" y="0"/>
-                </a:moveTo>
-                <a:lnTo>
-                  <a:pt x="1981200" y="0"/>
-                </a:lnTo>
-                <a:cubicBezTo>
-                  <a:pt x="1981200" y="0"/>
-                  <a:pt x="1981200" y="0"/>
-                  <a:pt x="1981200" y="0"/>
-                </a:cubicBezTo>
-                <a:lnTo>
-                  <a:pt x="1981200" y="787400"/>
-                </a:lnTo>
-                <a:cubicBezTo>
-                  <a:pt x="1981200" y="857542"/>
-                  <a:pt x="1924342" y="914400"/>
-                  <a:pt x="1854200" y="914400"/>
-                </a:cubicBezTo>
-                <a:lnTo>
-                  <a:pt x="127000" y="914400"/>
-                </a:lnTo>
-                <a:cubicBezTo>
-                  <a:pt x="56858" y="914400"/>
-                  <a:pt x="0" y="857542"/>
-                  <a:pt x="0" y="787400"/>
-                </a:cubicBezTo>
-                <a:lnTo>
-                  <a:pt x="0" y="0"/>
-                </a:lnTo>
-                <a:cubicBezTo>
-                  <a:pt x="0" y="0"/>
-                  <a:pt x="0" y="0"/>
-                  <a:pt x="0" y="0"/>
-                </a:cubicBezTo>
-                <a:close/>
-              </a:path>
-            </a:pathLst>
-          </a:custGeom>
-          <a:solidFill>
-            <a:srgbClr val="E8EEF6"/>
-          </a:solidFill>
-          <a:ln>
-            <a:noFill/>
-          </a:ln>
-        </p:spPr>
-        <p:txBody>
-          <a:bodyPr rtlCol="0" anchor="ctr"/>
-          <a:lstStyle/>
-          <a:p>
-            <a:pPr algn="ctr"/>
-            <a:endParaRPr lang="ko-KR" dirty="0"/>
-          </a:p>
-        </p:txBody>
-      </p:sp>
-      <p:sp>
-        <p:nvSpPr>
-          <p:cNvPr id="15" name="ch k2"/>
-          <p:cNvSpPr/>
-          <p:nvPr/>
-        </p:nvSpPr>
-        <p:spPr>
-          <a:xfrm>
-            <a:off x="2717800" y="2378174"/>
-            <a:ext cx="1981200" cy="2946400"/>
-          </a:xfrm>
-          <a:prstGeom prst="roundRect">
-            <a:avLst>
-              <a:gd name="adj" fmla="val 6410"/>
-            </a:avLst>
-          </a:prstGeom>
-          <a:solidFill>
-            <a:srgbClr val="F3F5F8"/>
-          </a:solidFill>
-          <a:ln>
-            <a:noFill/>
-          </a:ln>
-        </p:spPr>
-        <p:txBody>
-          <a:bodyPr rtlCol="0" anchor="ctr"/>
-          <a:lstStyle/>
-          <a:p>
-            <a:pPr algn="ctr"/>
-            <a:endParaRPr lang="ko-KR" dirty="0"/>
-          </a:p>
-        </p:txBody>
-      </p:sp>
-      <p:sp>
-        <p:nvSpPr>
-          <p:cNvPr id="16" name="svg circle"/>
-          <p:cNvSpPr/>
-          <p:nvPr/>
-        </p:nvSpPr>
-        <p:spPr>
-          <a:xfrm>
-            <a:off x="4305300" y="2695674"/>
-            <a:ext cx="177800" cy="177800"/>
-          </a:xfrm>
-          <a:prstGeom prst="ellipse">
-            <a:avLst/>
-          </a:prstGeom>
-          <a:noFill/>
-          <a:ln w="12700" cap="rnd">
-            <a:solidFill>
-              <a:srgbClr val="2B4A78"/>
-            </a:solidFill>
-            <a:round/>
-          </a:ln>
-        </p:spPr>
-        <p:txBody>
-          <a:bodyPr rtlCol="0" anchor="ctr"/>
-          <a:lstStyle/>
-          <a:p>
-            <a:pPr algn="ctr"/>
-            <a:endParaRPr lang="ko-KR" dirty="0"/>
-          </a:p>
-        </p:txBody>
-      </p:sp>
-      <p:sp>
-        <p:nvSpPr>
-          <p:cNvPr id="17" name="svg circle"/>
-          <p:cNvSpPr/>
-          <p:nvPr/>
-        </p:nvSpPr>
-        <p:spPr>
-          <a:xfrm>
-            <a:off x="4343400" y="2733774"/>
-            <a:ext cx="101600" cy="101600"/>
-          </a:xfrm>
-          <a:prstGeom prst="ellipse">
-            <a:avLst/>
-          </a:prstGeom>
-          <a:noFill/>
-          <a:ln w="12700" cap="rnd">
-            <a:solidFill>
-              <a:srgbClr val="2B4A78"/>
-            </a:solidFill>
-            <a:round/>
-          </a:ln>
-        </p:spPr>
-        <p:txBody>
-          <a:bodyPr rtlCol="0" anchor="ctr"/>
-          <a:lstStyle/>
-          <a:p>
-            <a:pPr algn="ctr"/>
-            <a:endParaRPr lang="ko-KR" dirty="0"/>
-          </a:p>
-        </p:txBody>
-      </p:sp>
-      <p:sp>
-        <p:nvSpPr>
-          <p:cNvPr id="18" name="svg circle"/>
-          <p:cNvSpPr/>
-          <p:nvPr/>
-        </p:nvSpPr>
-        <p:spPr>
-          <a:xfrm>
-            <a:off x="4381500" y="2771874"/>
-            <a:ext cx="25400" cy="25400"/>
-          </a:xfrm>
-          <a:prstGeom prst="ellipse">
-            <a:avLst/>
-          </a:prstGeom>
-          <a:noFill/>
-          <a:ln w="12700" cap="rnd">
-            <a:solidFill>
-              <a:srgbClr val="2B4A78"/>
-            </a:solidFill>
-            <a:round/>
-          </a:ln>
-        </p:spPr>
-        <p:txBody>
-          <a:bodyPr rtlCol="0" anchor="ctr"/>
-          <a:lstStyle/>
-          <a:p>
-            <a:pPr algn="ctr"/>
-            <a:endParaRPr lang="ko-KR" dirty="0"/>
-          </a:p>
-        </p:txBody>
-      </p:sp>
-      <p:sp>
-        <p:nvSpPr>
-          <p:cNvPr id="19" name="bar"/>
-          <p:cNvSpPr/>
-          <p:nvPr/>
-        </p:nvSpPr>
-        <p:spPr>
-          <a:xfrm>
-            <a:off x="2921000" y="3267174"/>
-            <a:ext cx="203200" cy="19050"/>
-          </a:xfrm>
-          <a:prstGeom prst="roundRect">
-            <a:avLst>
-              <a:gd name="adj" fmla="val 50000"/>
-            </a:avLst>
-          </a:prstGeom>
-          <a:solidFill>
-            <a:srgbClr val="102A4C"/>
-          </a:solidFill>
-          <a:ln>
-            <a:noFill/>
-          </a:ln>
-        </p:spPr>
-        <p:txBody>
-          <a:bodyPr rtlCol="0" anchor="ctr"/>
-          <a:lstStyle/>
-          <a:p>
-            <a:pPr algn="ctr"/>
-            <a:endParaRPr lang="ko-KR" dirty="0"/>
-          </a:p>
-        </p:txBody>
-      </p:sp>
-      <p:sp>
-        <p:nvSpPr>
-          <p:cNvPr id="20" name="q"/>
-          <p:cNvSpPr/>
-          <p:nvPr/>
-        </p:nvSpPr>
-        <p:spPr>
-          <a:xfrm>
-            <a:off x="2717800" y="4410174"/>
-            <a:ext cx="1981200" cy="914400"/>
-          </a:xfrm>
-          <a:custGeom>
-            <a:avLst/>
-            <a:gdLst/>
-            <a:ahLst/>
-            <a:cxnLst/>
-            <a:rect l="0" t="0" r="r" b="b"/>
-            <a:pathLst>
-              <a:path w="1981200" h="914400" stroke="0">
-                <a:moveTo>
-                  <a:pt x="0" y="0"/>
-                </a:moveTo>
-                <a:lnTo>
-                  <a:pt x="1981200" y="0"/>
-                </a:lnTo>
-                <a:cubicBezTo>
-                  <a:pt x="1981200" y="0"/>
-                  <a:pt x="1981200" y="0"/>
-                  <a:pt x="1981200" y="0"/>
-                </a:cubicBezTo>
-                <a:lnTo>
-                  <a:pt x="1981200" y="787400"/>
-                </a:lnTo>
-                <a:cubicBezTo>
-                  <a:pt x="1981200" y="857542"/>
-                  <a:pt x="1924342" y="914400"/>
-                  <a:pt x="1854200" y="914400"/>
-                </a:cubicBezTo>
-                <a:lnTo>
-                  <a:pt x="127000" y="914400"/>
-                </a:lnTo>
-                <a:cubicBezTo>
-                  <a:pt x="56858" y="914400"/>
-                  <a:pt x="0" y="857542"/>
-                  <a:pt x="0" y="787400"/>
-                </a:cubicBezTo>
-                <a:lnTo>
-                  <a:pt x="0" y="0"/>
-                </a:lnTo>
-                <a:cubicBezTo>
-                  <a:pt x="0" y="0"/>
-                  <a:pt x="0" y="0"/>
-                  <a:pt x="0" y="0"/>
-                </a:cubicBezTo>
-                <a:close/>
-              </a:path>
-            </a:pathLst>
-          </a:custGeom>
-          <a:solidFill>
-            <a:srgbClr val="E8EEF6"/>
-          </a:solidFill>
-          <a:ln>
-            <a:noFill/>
-          </a:ln>
-        </p:spPr>
-        <p:txBody>
-          <a:bodyPr rtlCol="0" anchor="ctr"/>
-          <a:lstStyle/>
-          <a:p>
-            <a:pPr algn="ctr"/>
-            <a:endParaRPr lang="ko-KR" dirty="0"/>
-          </a:p>
-        </p:txBody>
-      </p:sp>
-      <p:sp>
-        <p:nvSpPr>
-          <p:cNvPr id="21" name="ch k3"/>
-          <p:cNvSpPr/>
-          <p:nvPr/>
-        </p:nvSpPr>
-        <p:spPr>
-          <a:xfrm>
-            <a:off x="5105400" y="2378174"/>
-            <a:ext cx="1981200" cy="2946400"/>
-          </a:xfrm>
-          <a:prstGeom prst="roundRect">
-            <a:avLst>
-              <a:gd name="adj" fmla="val 6410"/>
-            </a:avLst>
-          </a:prstGeom>
-          <a:solidFill>
-            <a:srgbClr val="F3F5F8"/>
-          </a:solidFill>
-          <a:ln>
-            <a:noFill/>
-          </a:ln>
-        </p:spPr>
-        <p:txBody>
-          <a:bodyPr rtlCol="0" anchor="ctr"/>
-          <a:lstStyle/>
-          <a:p>
-            <a:pPr algn="ctr"/>
-            <a:endParaRPr lang="ko-KR" dirty="0"/>
-          </a:p>
-        </p:txBody>
-      </p:sp>
-      <p:sp>
-        <p:nvSpPr>
-          <p:cNvPr id="22" name="svg rect"/>
-          <p:cNvSpPr/>
-          <p:nvPr/>
-        </p:nvSpPr>
-        <p:spPr>
-          <a:xfrm>
-            <a:off x="6680200" y="2752824"/>
-            <a:ext cx="63500" cy="63500"/>
-          </a:xfrm>
-          <a:prstGeom prst="roundRect">
-            <a:avLst>
-              <a:gd name="adj" fmla="val 20000"/>
-            </a:avLst>
-          </a:prstGeom>
-          <a:noFill/>
-          <a:ln w="12700" cap="rnd">
-            <a:solidFill>
-              <a:srgbClr val="2B4A78"/>
-            </a:solidFill>
-            <a:round/>
-          </a:ln>
-        </p:spPr>
-        <p:txBody>
-          <a:bodyPr rtlCol="0" anchor="ctr"/>
-          <a:lstStyle/>
-          <a:p>
-            <a:pPr algn="ctr"/>
-            <a:endParaRPr lang="ko-KR" dirty="0"/>
-          </a:p>
-        </p:txBody>
-      </p:sp>
-      <p:sp>
-        <p:nvSpPr>
-          <p:cNvPr id="23" name="svg rect"/>
-          <p:cNvSpPr/>
-          <p:nvPr/>
-        </p:nvSpPr>
-        <p:spPr>
-          <a:xfrm>
-            <a:off x="6819900" y="2689324"/>
-            <a:ext cx="63500" cy="63500"/>
-          </a:xfrm>
-          <a:prstGeom prst="roundRect">
-            <a:avLst>
-              <a:gd name="adj" fmla="val 20000"/>
-            </a:avLst>
-          </a:prstGeom>
-          <a:noFill/>
-          <a:ln w="12700" cap="rnd">
-            <a:solidFill>
-              <a:srgbClr val="2B4A78"/>
-            </a:solidFill>
-            <a:round/>
-          </a:ln>
-        </p:spPr>
-        <p:txBody>
-          <a:bodyPr rtlCol="0" anchor="ctr"/>
-          <a:lstStyle/>
-          <a:p>
-            <a:pPr algn="ctr"/>
-            <a:endParaRPr lang="ko-KR" dirty="0"/>
-          </a:p>
-        </p:txBody>
-      </p:sp>
-      <p:sp>
-        <p:nvSpPr>
-          <p:cNvPr id="24" name="svg rect"/>
-          <p:cNvSpPr/>
-          <p:nvPr/>
-        </p:nvSpPr>
-        <p:spPr>
-          <a:xfrm>
-            <a:off x="6819900" y="2816324"/>
-            <a:ext cx="63500" cy="63500"/>
-          </a:xfrm>
-          <a:prstGeom prst="roundRect">
-            <a:avLst>
-              <a:gd name="adj" fmla="val 20000"/>
-            </a:avLst>
-          </a:prstGeom>
-          <a:noFill/>
-          <a:ln w="12700" cap="rnd">
-            <a:solidFill>
-              <a:srgbClr val="2B4A78"/>
-            </a:solidFill>
-            <a:round/>
-          </a:ln>
-        </p:spPr>
-        <p:txBody>
-          <a:bodyPr rtlCol="0" anchor="ctr"/>
-          <a:lstStyle/>
-          <a:p>
-            <a:pPr algn="ctr"/>
-            <a:endParaRPr lang="ko-KR" dirty="0"/>
-          </a:p>
-        </p:txBody>
-      </p:sp>
-      <p:sp>
-        <p:nvSpPr>
-          <p:cNvPr id="25" name="svg path"/>
-          <p:cNvSpPr/>
-          <p:nvPr/>
-        </p:nvSpPr>
-        <p:spPr>
-          <a:xfrm>
-            <a:off x="6743700" y="2721074"/>
-            <a:ext cx="76200" cy="127000"/>
-          </a:xfrm>
-          <a:custGeom>
-            <a:avLst/>
-            <a:gdLst/>
-            <a:ahLst/>
-            <a:cxnLst/>
-            <a:rect l="0" t="0" r="r" b="b"/>
-            <a:pathLst>
-              <a:path w="76200" h="127000" fill="none">
-                <a:moveTo>
-                  <a:pt x="0" y="63500"/>
-                </a:moveTo>
-                <a:lnTo>
-                  <a:pt x="38100" y="63500"/>
-                </a:lnTo>
-                <a:moveTo>
-                  <a:pt x="38100" y="0"/>
-                </a:moveTo>
-                <a:lnTo>
-                  <a:pt x="38100" y="127000"/>
-                </a:lnTo>
-                <a:moveTo>
-                  <a:pt x="38100" y="0"/>
-                </a:moveTo>
-                <a:lnTo>
-                  <a:pt x="76200" y="0"/>
-                </a:lnTo>
-                <a:moveTo>
-                  <a:pt x="38100" y="127000"/>
-                </a:moveTo>
-                <a:lnTo>
-                  <a:pt x="76200" y="127000"/>
-                </a:lnTo>
-              </a:path>
-            </a:pathLst>
-          </a:custGeom>
-          <a:noFill/>
-          <a:ln w="12700" cap="rnd">
-            <a:solidFill>
-              <a:srgbClr val="2B4A78"/>
-            </a:solidFill>
-            <a:round/>
-          </a:ln>
-        </p:spPr>
-        <p:txBody>
-          <a:bodyPr rtlCol="0" anchor="ctr"/>
-          <a:lstStyle/>
-          <a:p>
-            <a:pPr algn="ctr"/>
-            <a:endParaRPr lang="ko-KR" dirty="0"/>
-          </a:p>
-        </p:txBody>
-      </p:sp>
-      <p:sp>
-        <p:nvSpPr>
-          <p:cNvPr id="26" name="bar"/>
-          <p:cNvSpPr/>
-          <p:nvPr/>
-        </p:nvSpPr>
-        <p:spPr>
-          <a:xfrm>
-            <a:off x="5308600" y="3267174"/>
-            <a:ext cx="203200" cy="19050"/>
-          </a:xfrm>
-          <a:prstGeom prst="roundRect">
-            <a:avLst>
-              <a:gd name="adj" fmla="val 50000"/>
-            </a:avLst>
-          </a:prstGeom>
-          <a:solidFill>
-            <a:srgbClr val="102A4C"/>
-          </a:solidFill>
-          <a:ln>
-            <a:noFill/>
-          </a:ln>
-        </p:spPr>
-        <p:txBody>
-          <a:bodyPr rtlCol="0" anchor="ctr"/>
-          <a:lstStyle/>
-          <a:p>
-            <a:pPr algn="ctr"/>
-            <a:endParaRPr lang="ko-KR" dirty="0"/>
-          </a:p>
-        </p:txBody>
-      </p:sp>
-      <p:sp>
-        <p:nvSpPr>
-          <p:cNvPr id="27" name="q"/>
-          <p:cNvSpPr/>
-          <p:nvPr/>
-        </p:nvSpPr>
-        <p:spPr>
-          <a:xfrm>
-            <a:off x="5105400" y="4410174"/>
-            <a:ext cx="1981200" cy="914400"/>
-          </a:xfrm>
-          <a:custGeom>
-            <a:avLst/>
-            <a:gdLst/>
-            <a:ahLst/>
-            <a:cxnLst/>
-            <a:rect l="0" t="0" r="r" b="b"/>
-            <a:pathLst>
-              <a:path w="1981200" h="914400" stroke="0">
-                <a:moveTo>
-                  <a:pt x="0" y="0"/>
-                </a:moveTo>
-                <a:lnTo>
-                  <a:pt x="1981200" y="0"/>
-                </a:lnTo>
-                <a:cubicBezTo>
-                  <a:pt x="1981200" y="0"/>
-                  <a:pt x="1981200" y="0"/>
-                  <a:pt x="1981200" y="0"/>
-                </a:cubicBezTo>
-                <a:lnTo>
-                  <a:pt x="1981200" y="787400"/>
-                </a:lnTo>
-                <a:cubicBezTo>
-                  <a:pt x="1981200" y="857542"/>
-                  <a:pt x="1924342" y="914400"/>
-                  <a:pt x="1854200" y="914400"/>
-                </a:cubicBezTo>
-                <a:lnTo>
-                  <a:pt x="127000" y="914400"/>
-                </a:lnTo>
-                <a:cubicBezTo>
-                  <a:pt x="56858" y="914400"/>
-                  <a:pt x="0" y="857542"/>
-                  <a:pt x="0" y="787400"/>
-                </a:cubicBezTo>
-                <a:lnTo>
-                  <a:pt x="0" y="0"/>
-                </a:lnTo>
-                <a:cubicBezTo>
-                  <a:pt x="0" y="0"/>
-                  <a:pt x="0" y="0"/>
-                  <a:pt x="0" y="0"/>
-                </a:cubicBezTo>
-                <a:close/>
-              </a:path>
-            </a:pathLst>
-          </a:custGeom>
-          <a:solidFill>
-            <a:srgbClr val="E8EEF6"/>
-          </a:solidFill>
-          <a:ln>
-            <a:noFill/>
-          </a:ln>
-        </p:spPr>
-        <p:txBody>
-          <a:bodyPr rtlCol="0" anchor="ctr"/>
-          <a:lstStyle/>
-          <a:p>
-            <a:pPr algn="ctr"/>
-            <a:endParaRPr lang="ko-KR" dirty="0"/>
-          </a:p>
-        </p:txBody>
-      </p:sp>
-      <p:sp>
-        <p:nvSpPr>
-          <p:cNvPr id="28" name="ch k4"/>
-          <p:cNvSpPr/>
-          <p:nvPr/>
-        </p:nvSpPr>
-        <p:spPr>
-          <a:xfrm>
-            <a:off x="7213600" y="2378174"/>
-            <a:ext cx="1981200" cy="2946400"/>
-          </a:xfrm>
-          <a:prstGeom prst="roundRect">
-            <a:avLst>
-              <a:gd name="adj" fmla="val 6410"/>
-            </a:avLst>
-          </a:prstGeom>
-          <a:solidFill>
-            <a:srgbClr val="F3F5F8"/>
-          </a:solidFill>
-          <a:ln>
-            <a:noFill/>
-          </a:ln>
-        </p:spPr>
-        <p:txBody>
-          <a:bodyPr rtlCol="0" anchor="ctr"/>
-          <a:lstStyle/>
-          <a:p>
-            <a:pPr algn="ctr"/>
-            <a:endParaRPr lang="ko-KR" dirty="0"/>
-          </a:p>
-        </p:txBody>
-      </p:sp>
-      <p:sp>
-        <p:nvSpPr>
-          <p:cNvPr id="29" name="svg path"/>
-          <p:cNvSpPr/>
-          <p:nvPr/>
-        </p:nvSpPr>
-        <p:spPr>
-          <a:xfrm>
-            <a:off x="8794750" y="2879824"/>
-            <a:ext cx="190500" cy="1"/>
-          </a:xfrm>
-          <a:custGeom>
-            <a:avLst/>
-            <a:gdLst/>
-            <a:ahLst/>
-            <a:cxnLst/>
-            <a:rect l="0" t="0" r="r" b="b"/>
-            <a:pathLst>
-              <a:path w="190500" h="1" fill="none">
-                <a:moveTo>
-                  <a:pt x="0" y="0"/>
-                </a:moveTo>
-                <a:lnTo>
-                  <a:pt x="190500" y="0"/>
-                </a:lnTo>
-              </a:path>
-            </a:pathLst>
-          </a:custGeom>
-          <a:noFill/>
-          <a:ln w="12700" cap="rnd">
-            <a:solidFill>
-              <a:srgbClr val="2B4A78"/>
-            </a:solidFill>
-            <a:round/>
-          </a:ln>
-        </p:spPr>
-        <p:txBody>
-          <a:bodyPr rtlCol="0" anchor="ctr"/>
-          <a:lstStyle/>
-          <a:p>
-            <a:pPr algn="ctr"/>
-            <a:endParaRPr lang="ko-KR" dirty="0"/>
-          </a:p>
-        </p:txBody>
-      </p:sp>
-      <p:sp>
-        <p:nvSpPr>
-          <p:cNvPr id="30" name="svg rect"/>
-          <p:cNvSpPr/>
-          <p:nvPr/>
-        </p:nvSpPr>
-        <p:spPr>
-          <a:xfrm>
-            <a:off x="8813800" y="2803624"/>
-            <a:ext cx="38100" cy="76200"/>
-          </a:xfrm>
-          <a:prstGeom prst="roundRect">
-            <a:avLst>
-              <a:gd name="adj" fmla="val 16667"/>
-            </a:avLst>
-          </a:prstGeom>
-          <a:noFill/>
-          <a:ln w="12700" cap="rnd">
-            <a:solidFill>
-              <a:srgbClr val="2B4A78"/>
-            </a:solidFill>
-            <a:round/>
-          </a:ln>
-        </p:spPr>
-        <p:txBody>
-          <a:bodyPr rtlCol="0" anchor="ctr"/>
-          <a:lstStyle/>
-          <a:p>
-            <a:pPr algn="ctr"/>
-            <a:endParaRPr lang="ko-KR" dirty="0"/>
-          </a:p>
-        </p:txBody>
-      </p:sp>
-      <p:sp>
-        <p:nvSpPr>
-          <p:cNvPr id="31" name="svg rect"/>
-          <p:cNvSpPr/>
-          <p:nvPr/>
-        </p:nvSpPr>
-        <p:spPr>
-          <a:xfrm>
-            <a:off x="8870950" y="2752824"/>
-            <a:ext cx="38100" cy="127000"/>
-          </a:xfrm>
-          <a:prstGeom prst="roundRect">
-            <a:avLst>
-              <a:gd name="adj" fmla="val 16667"/>
-            </a:avLst>
-          </a:prstGeom>
-          <a:noFill/>
-          <a:ln w="12700" cap="rnd">
-            <a:solidFill>
-              <a:srgbClr val="2B4A78"/>
-            </a:solidFill>
-            <a:round/>
-          </a:ln>
-        </p:spPr>
-        <p:txBody>
-          <a:bodyPr rtlCol="0" anchor="ctr"/>
-          <a:lstStyle/>
-          <a:p>
-            <a:pPr algn="ctr"/>
-            <a:endParaRPr lang="ko-KR" dirty="0"/>
-          </a:p>
-        </p:txBody>
-      </p:sp>
-      <p:sp>
-        <p:nvSpPr>
-          <p:cNvPr id="32" name="svg rect"/>
-          <p:cNvSpPr/>
-          <p:nvPr/>
-        </p:nvSpPr>
-        <p:spPr>
-          <a:xfrm>
-            <a:off x="8928100" y="2702024"/>
-            <a:ext cx="38100" cy="177800"/>
-          </a:xfrm>
-          <a:prstGeom prst="roundRect">
-            <a:avLst>
-              <a:gd name="adj" fmla="val 16667"/>
-            </a:avLst>
-          </a:prstGeom>
-          <a:noFill/>
-          <a:ln w="12700" cap="rnd">
-            <a:solidFill>
-              <a:srgbClr val="2B4A78"/>
-            </a:solidFill>
-            <a:round/>
-          </a:ln>
-        </p:spPr>
-        <p:txBody>
-          <a:bodyPr rtlCol="0" anchor="ctr"/>
-          <a:lstStyle/>
-          <a:p>
-            <a:pPr algn="ctr"/>
-            <a:endParaRPr lang="ko-KR" dirty="0"/>
-          </a:p>
-        </p:txBody>
-      </p:sp>
-      <p:sp>
-        <p:nvSpPr>
-          <p:cNvPr id="33" name="bar"/>
-          <p:cNvSpPr/>
-          <p:nvPr/>
-        </p:nvSpPr>
-        <p:spPr>
-          <a:xfrm>
-            <a:off x="7416800" y="3267174"/>
-            <a:ext cx="203200" cy="19050"/>
-          </a:xfrm>
-          <a:prstGeom prst="roundRect">
-            <a:avLst>
-              <a:gd name="adj" fmla="val 50000"/>
-            </a:avLst>
-          </a:prstGeom>
-          <a:solidFill>
-            <a:srgbClr val="102A4C"/>
-          </a:solidFill>
-          <a:ln>
-            <a:noFill/>
-          </a:ln>
-        </p:spPr>
-        <p:txBody>
-          <a:bodyPr rtlCol="0" anchor="ctr"/>
-          <a:lstStyle/>
-          <a:p>
-            <a:pPr algn="ctr"/>
-            <a:endParaRPr lang="ko-KR" dirty="0"/>
-          </a:p>
-        </p:txBody>
-      </p:sp>
-      <p:sp>
-        <p:nvSpPr>
-          <p:cNvPr id="34" name="q"/>
-          <p:cNvSpPr/>
-          <p:nvPr/>
-        </p:nvSpPr>
-        <p:spPr>
-          <a:xfrm>
-            <a:off x="7213600" y="4410174"/>
-            <a:ext cx="1981200" cy="914400"/>
-          </a:xfrm>
-          <a:custGeom>
-            <a:avLst/>
-            <a:gdLst/>
-            <a:ahLst/>
-            <a:cxnLst/>
-            <a:rect l="0" t="0" r="r" b="b"/>
-            <a:pathLst>
-              <a:path w="1981200" h="914400" stroke="0">
-                <a:moveTo>
-                  <a:pt x="0" y="0"/>
-                </a:moveTo>
-                <a:lnTo>
-                  <a:pt x="1981200" y="0"/>
-                </a:lnTo>
-                <a:cubicBezTo>
-                  <a:pt x="1981200" y="0"/>
-                  <a:pt x="1981200" y="0"/>
-                  <a:pt x="1981200" y="0"/>
-                </a:cubicBezTo>
-                <a:lnTo>
-                  <a:pt x="1981200" y="787400"/>
-                </a:lnTo>
-                <a:cubicBezTo>
-                  <a:pt x="1981200" y="857542"/>
-                  <a:pt x="1924342" y="914400"/>
-                  <a:pt x="1854200" y="914400"/>
-                </a:cubicBezTo>
-                <a:lnTo>
-                  <a:pt x="127000" y="914400"/>
-                </a:lnTo>
-                <a:cubicBezTo>
-                  <a:pt x="56858" y="914400"/>
-                  <a:pt x="0" y="857542"/>
-                  <a:pt x="0" y="787400"/>
-                </a:cubicBezTo>
-                <a:lnTo>
-                  <a:pt x="0" y="0"/>
-                </a:lnTo>
-                <a:cubicBezTo>
-                  <a:pt x="0" y="0"/>
-                  <a:pt x="0" y="0"/>
-                  <a:pt x="0" y="0"/>
-                </a:cubicBezTo>
-                <a:close/>
-              </a:path>
-            </a:pathLst>
-          </a:custGeom>
-          <a:solidFill>
-            <a:srgbClr val="E8EEF6"/>
-          </a:solidFill>
-          <a:ln>
-            <a:noFill/>
-          </a:ln>
-        </p:spPr>
-        <p:txBody>
-          <a:bodyPr rtlCol="0" anchor="ctr"/>
-          <a:lstStyle/>
-          <a:p>
-            <a:pPr algn="ctr"/>
-            <a:endParaRPr lang="ko-KR" dirty="0"/>
-          </a:p>
-        </p:txBody>
-      </p:sp>
-      <p:sp>
-        <p:nvSpPr>
-          <p:cNvPr id="35" name="ch k5"/>
-          <p:cNvSpPr/>
-          <p:nvPr/>
-        </p:nvSpPr>
-        <p:spPr>
-          <a:xfrm>
-            <a:off x="9601200" y="2378174"/>
-            <a:ext cx="1981200" cy="2946400"/>
-          </a:xfrm>
-          <a:prstGeom prst="roundRect">
-            <a:avLst>
-              <a:gd name="adj" fmla="val 6410"/>
-            </a:avLst>
-          </a:prstGeom>
-          <a:solidFill>
-            <a:srgbClr val="102A4C"/>
-          </a:solidFill>
-          <a:ln>
-            <a:noFill/>
-          </a:ln>
-        </p:spPr>
-        <p:txBody>
-          <a:bodyPr rtlCol="0" anchor="ctr"/>
-          <a:lstStyle/>
-          <a:p>
-            <a:pPr algn="ctr"/>
-            <a:endParaRPr lang="ko-KR" dirty="0"/>
-          </a:p>
-        </p:txBody>
-      </p:sp>
-      <p:sp>
-        <p:nvSpPr>
-          <p:cNvPr id="36" name="svg path"/>
-          <p:cNvSpPr/>
-          <p:nvPr/>
-        </p:nvSpPr>
-        <p:spPr>
-          <a:xfrm>
-            <a:off x="11169650" y="2879824"/>
-            <a:ext cx="215900" cy="1"/>
-          </a:xfrm>
-          <a:custGeom>
-            <a:avLst/>
-            <a:gdLst/>
-            <a:ahLst/>
-            <a:cxnLst/>
-            <a:rect l="0" t="0" r="r" b="b"/>
-            <a:pathLst>
-              <a:path w="215900" h="1" fill="none">
-                <a:moveTo>
-                  <a:pt x="0" y="0"/>
-                </a:moveTo>
-                <a:lnTo>
-                  <a:pt x="215900" y="0"/>
-                </a:lnTo>
-              </a:path>
-            </a:pathLst>
-          </a:custGeom>
-          <a:noFill/>
-          <a:ln w="12700" cap="rnd">
-            <a:solidFill>
-              <a:srgbClr val="9FB0C8"/>
-            </a:solidFill>
-            <a:round/>
-          </a:ln>
-        </p:spPr>
-        <p:txBody>
-          <a:bodyPr rtlCol="0" anchor="ctr"/>
-          <a:lstStyle/>
-          <a:p>
-            <a:pPr algn="ctr"/>
-            <a:endParaRPr lang="ko-KR" dirty="0"/>
-          </a:p>
-        </p:txBody>
-      </p:sp>
-      <p:sp>
-        <p:nvSpPr>
-          <p:cNvPr id="37" name="svg path"/>
-          <p:cNvSpPr/>
-          <p:nvPr/>
-        </p:nvSpPr>
-        <p:spPr>
-          <a:xfrm>
-            <a:off x="11188700" y="2702024"/>
-            <a:ext cx="171450" cy="177800"/>
-          </a:xfrm>
-          <a:custGeom>
-            <a:avLst/>
-            <a:gdLst/>
-            <a:ahLst/>
-            <a:cxnLst/>
-            <a:rect l="0" t="0" r="r" b="b"/>
-            <a:pathLst>
-              <a:path w="171450" h="177800" fill="none">
-                <a:moveTo>
-                  <a:pt x="0" y="177800"/>
-                </a:moveTo>
-                <a:lnTo>
-                  <a:pt x="0" y="82550"/>
-                </a:lnTo>
-                <a:lnTo>
-                  <a:pt x="57150" y="44450"/>
-                </a:lnTo>
-                <a:lnTo>
-                  <a:pt x="57150" y="82550"/>
-                </a:lnTo>
-                <a:lnTo>
-                  <a:pt x="114300" y="44450"/>
-                </a:lnTo>
-                <a:lnTo>
-                  <a:pt x="114300" y="82550"/>
-                </a:lnTo>
-                <a:lnTo>
-                  <a:pt x="133350" y="82550"/>
-                </a:lnTo>
-                <a:lnTo>
-                  <a:pt x="133350" y="0"/>
-                </a:lnTo>
-                <a:lnTo>
-                  <a:pt x="171450" y="0"/>
-                </a:lnTo>
-                <a:lnTo>
-                  <a:pt x="171450" y="177800"/>
-                </a:lnTo>
-              </a:path>
-            </a:pathLst>
-          </a:custGeom>
-          <a:noFill/>
-          <a:ln w="12700" cap="rnd">
-            <a:solidFill>
-              <a:srgbClr val="9FB0C8"/>
-            </a:solidFill>
-            <a:round/>
-          </a:ln>
-        </p:spPr>
-        <p:txBody>
-          <a:bodyPr rtlCol="0" anchor="ctr"/>
-          <a:lstStyle/>
-          <a:p>
-            <a:pPr algn="ctr"/>
-            <a:endParaRPr lang="ko-KR" dirty="0"/>
-          </a:p>
-        </p:txBody>
-      </p:sp>
-      <p:sp>
-        <p:nvSpPr>
-          <p:cNvPr id="38" name="svg path"/>
-          <p:cNvSpPr/>
-          <p:nvPr/>
-        </p:nvSpPr>
-        <p:spPr>
-          <a:xfrm>
-            <a:off x="11220450" y="2835374"/>
-            <a:ext cx="82550" cy="1"/>
-          </a:xfrm>
-          <a:custGeom>
-            <a:avLst/>
-            <a:gdLst/>
-            <a:ahLst/>
-            <a:cxnLst/>
-            <a:rect l="0" t="0" r="r" b="b"/>
-            <a:pathLst>
-              <a:path w="82550" h="1" fill="none">
-                <a:moveTo>
-                  <a:pt x="0" y="0"/>
-                </a:moveTo>
-                <a:lnTo>
-                  <a:pt x="25400" y="0"/>
-                </a:lnTo>
-                <a:moveTo>
-                  <a:pt x="57150" y="0"/>
-                </a:moveTo>
-                <a:lnTo>
-                  <a:pt x="82550" y="0"/>
-                </a:lnTo>
-              </a:path>
-            </a:pathLst>
-          </a:custGeom>
-          <a:noFill/>
-          <a:ln w="12700" cap="rnd">
-            <a:solidFill>
-              <a:srgbClr val="9FB0C8"/>
-            </a:solidFill>
-            <a:round/>
-          </a:ln>
-        </p:spPr>
-        <p:txBody>
-          <a:bodyPr rtlCol="0" anchor="ctr"/>
-          <a:lstStyle/>
-          <a:p>
-            <a:pPr algn="ctr"/>
-            <a:endParaRPr lang="ko-KR" dirty="0"/>
-          </a:p>
-        </p:txBody>
-      </p:sp>
-      <p:sp>
-        <p:nvSpPr>
-          <p:cNvPr id="39" name="bar"/>
-          <p:cNvSpPr/>
-          <p:nvPr/>
-        </p:nvSpPr>
-        <p:spPr>
-          <a:xfrm>
-            <a:off x="9804400" y="3267174"/>
-            <a:ext cx="203200" cy="19050"/>
-          </a:xfrm>
-          <a:prstGeom prst="roundRect">
-            <a:avLst>
-              <a:gd name="adj" fmla="val 50000"/>
-            </a:avLst>
-          </a:prstGeom>
-          <a:solidFill>
-            <a:srgbClr val="9FB0C8"/>
-          </a:solidFill>
-          <a:ln>
-            <a:noFill/>
-          </a:ln>
-        </p:spPr>
-        <p:txBody>
-          <a:bodyPr rtlCol="0" anchor="ctr"/>
-          <a:lstStyle/>
-          <a:p>
-            <a:pPr algn="ctr"/>
-            <a:endParaRPr lang="ko-KR" dirty="0"/>
-          </a:p>
-        </p:txBody>
-      </p:sp>
-      <p:sp>
-        <p:nvSpPr>
-          <p:cNvPr id="40" name="q"/>
-          <p:cNvSpPr/>
-          <p:nvPr/>
-        </p:nvSpPr>
-        <p:spPr>
-          <a:xfrm>
-            <a:off x="9601200" y="4410174"/>
-            <a:ext cx="1981200" cy="914400"/>
-          </a:xfrm>
-          <a:custGeom>
-            <a:avLst/>
-            <a:gdLst/>
-            <a:ahLst/>
-            <a:cxnLst/>
-            <a:rect l="0" t="0" r="r" b="b"/>
-            <a:pathLst>
-              <a:path w="1981200" h="914400" stroke="0">
-                <a:moveTo>
-                  <a:pt x="0" y="0"/>
-                </a:moveTo>
-                <a:lnTo>
-                  <a:pt x="1981200" y="0"/>
-                </a:lnTo>
-                <a:cubicBezTo>
-                  <a:pt x="1981200" y="0"/>
-                  <a:pt x="1981200" y="0"/>
-                  <a:pt x="1981200" y="0"/>
-                </a:cubicBezTo>
-                <a:lnTo>
-                  <a:pt x="1981200" y="787400"/>
-                </a:lnTo>
-                <a:cubicBezTo>
-                  <a:pt x="1981200" y="857542"/>
-                  <a:pt x="1924342" y="914400"/>
-                  <a:pt x="1854200" y="914400"/>
-                </a:cubicBezTo>
-                <a:lnTo>
-                  <a:pt x="127000" y="914400"/>
-                </a:lnTo>
-                <a:cubicBezTo>
-                  <a:pt x="56858" y="914400"/>
-                  <a:pt x="0" y="857542"/>
-                  <a:pt x="0" y="787400"/>
-                </a:cubicBezTo>
-                <a:lnTo>
-                  <a:pt x="0" y="0"/>
-                </a:lnTo>
-                <a:cubicBezTo>
-                  <a:pt x="0" y="0"/>
-                  <a:pt x="0" y="0"/>
-                  <a:pt x="0" y="0"/>
-                </a:cubicBezTo>
-                <a:close/>
-              </a:path>
-            </a:pathLst>
-          </a:custGeom>
-          <a:solidFill>
-            <a:srgbClr val="213D63"/>
-          </a:solidFill>
-          <a:ln>
-            <a:noFill/>
-          </a:ln>
-        </p:spPr>
-        <p:txBody>
-          <a:bodyPr rtlCol="0" anchor="ctr"/>
-          <a:lstStyle/>
-          <a:p>
-            <a:pPr algn="ctr"/>
-            <a:endParaRPr lang="ko-KR" dirty="0"/>
-          </a:p>
-        </p:txBody>
-      </p:sp>
-      <p:sp>
-        <p:nvSpPr>
-          <p:cNvPr id="41" name="00"/>
-          <p:cNvSpPr txBox="1"/>
-          <p:nvPr/>
-        </p:nvSpPr>
-        <p:spPr>
-          <a:xfrm>
-            <a:off x="609600" y="401439"/>
-            <a:ext cx="220166" cy="146050"/>
+          <p:cNvPr id="20" name="석사 연구 발표"/>
+          <p:cNvSpPr txBox="1"/>
+          <p:nvPr/>
+        </p:nvSpPr>
+        <p:spPr>
+          <a:xfrm>
+            <a:off x="876300" y="553839"/>
+            <a:ext cx="751384" cy="146050"/>
           </a:xfrm>
           <a:prstGeom prst="rect">
             <a:avLst/>
@@ -3306,30 +2336,162 @@
               <a:buNone/>
             </a:pPr>
             <a:r>
-              <a:rPr lang="ko-KR" altLang="en-US" sz="950" spc="19" kern="0" dirty="0">
-                <a:solidFill>
-                  <a:srgbClr val="EA002C"/>
+              <a:rPr lang="ko-KR" altLang="en-US" sz="950" b="1" spc="19" kern="0" dirty="0">
+                <a:solidFill>
+                  <a:srgbClr val="102A4C"/>
+                </a:solidFill>
+                <a:latin typeface="Pretendard" pitchFamily="34" charset="0"/>
+                <a:ea typeface="Pretendard" pitchFamily="34" charset="-127"/>
+                <a:cs typeface="Pretendard" pitchFamily="34" charset="-120"/>
+              </a:rPr>
+              <a:t>석사 연구 발표</a:t>
+            </a:r>
+            <a:endParaRPr lang="en-US" sz="950" dirty="0"/>
+          </a:p>
+        </p:txBody>
+      </p:sp>
+      <p:sp>
+        <p:nvSpPr>
+          <p:cNvPr id="21" name="평면도와 입면도 객체 인식 및 정보 통합을 통한"/>
+          <p:cNvSpPr txBox="1"/>
+          <p:nvPr/>
+        </p:nvSpPr>
+        <p:spPr>
+          <a:xfrm>
+            <a:off x="609600" y="2142728"/>
+            <a:ext cx="4610525" cy="304800"/>
+          </a:xfrm>
+          <a:prstGeom prst="rect">
+            <a:avLst/>
+          </a:prstGeom>
+          <a:noFill/>
+          <a:ln/>
+        </p:spPr>
+        <p:txBody>
+          <a:bodyPr wrap="none" lIns="0" tIns="0" rIns="0" bIns="0" rtlCol="0" anchor="ctr"/>
+          <a:lstStyle/>
+          <a:p>
+            <a:pPr algn="l" indent="0" marL="0">
+              <a:buNone/>
+            </a:pPr>
+            <a:r>
+              <a:rPr lang="ko-KR" altLang="en-US" sz="2000" b="1" spc="-70" kern="0" dirty="0">
+                <a:solidFill>
+                  <a:srgbClr val="3F4654"/>
+                </a:solidFill>
+                <a:latin typeface="Pretendard" pitchFamily="34" charset="0"/>
+                <a:ea typeface="Pretendard" pitchFamily="34" charset="-127"/>
+                <a:cs typeface="Pretendard" pitchFamily="34" charset="-120"/>
+              </a:rPr>
+              <a:t>평면도와 입면도 객체 인식 및 정보 통합을 통한</a:t>
+            </a:r>
+            <a:endParaRPr lang="en-US" sz="2000" dirty="0"/>
+          </a:p>
+        </p:txBody>
+      </p:sp>
+      <p:sp>
+        <p:nvSpPr>
+          <p:cNvPr id="22" name="3D BIM 자동 생성 연구"/>
+          <p:cNvSpPr txBox="1"/>
+          <p:nvPr/>
+        </p:nvSpPr>
+        <p:spPr>
+          <a:xfrm>
+            <a:off x="609600" y="2511028"/>
+            <a:ext cx="5304238" cy="698500"/>
+          </a:xfrm>
+          <a:prstGeom prst="rect">
+            <a:avLst/>
+          </a:prstGeom>
+          <a:noFill/>
+          <a:ln/>
+        </p:spPr>
+        <p:txBody>
+          <a:bodyPr wrap="none" lIns="0" tIns="0" rIns="0" bIns="0" rtlCol="0" anchor="ctr"/>
+          <a:lstStyle/>
+          <a:p>
+            <a:pPr algn="l" indent="0" marL="0">
+              <a:buNone/>
+            </a:pPr>
+            <a:r>
+              <a:rPr lang="ko-KR" altLang="en-US" sz="4600" spc="-207" kern="0" dirty="0">
+                <a:solidFill>
+                  <a:srgbClr val="102A4C"/>
                 </a:solidFill>
                 <a:latin typeface="Pretendard ExtraBold" pitchFamily="34" charset="0"/>
                 <a:ea typeface="Pretendard ExtraBold" pitchFamily="34" charset="-127"/>
                 <a:cs typeface="Pretendard ExtraBold" pitchFamily="34" charset="-120"/>
               </a:rPr>
-              <a:t>00</a:t>
-            </a:r>
-            <a:endParaRPr lang="en-US" sz="950" dirty="0"/>
-          </a:p>
-        </p:txBody>
-      </p:sp>
-      <p:sp>
-        <p:nvSpPr>
-          <p:cNvPr id="42" name="CONTENTS"/>
-          <p:cNvSpPr txBox="1"/>
-          <p:nvPr/>
-        </p:nvSpPr>
-        <p:spPr>
-          <a:xfrm>
-            <a:off x="867866" y="401439"/>
-            <a:ext cx="689967" cy="146050"/>
+              <a:t>3D BIM 자동 생성 연구</a:t>
+            </a:r>
+            <a:endParaRPr lang="en-US" sz="4600" dirty="0"/>
+          </a:p>
+        </p:txBody>
+      </p:sp>
+      <p:sp>
+        <p:nvSpPr>
+          <p:cNvPr id="23" name="Automated BIM generation from inconsiste"/>
+          <p:cNvSpPr txBox="1"/>
+          <p:nvPr/>
+        </p:nvSpPr>
+        <p:spPr>
+          <a:xfrm>
+            <a:off x="609600" y="3368477"/>
+            <a:ext cx="5610078" cy="419100"/>
+          </a:xfrm>
+          <a:prstGeom prst="rect">
+            <a:avLst/>
+          </a:prstGeom>
+          <a:noFill/>
+          <a:ln/>
+        </p:spPr>
+        <p:txBody>
+          <a:bodyPr wrap="none" lIns="0" tIns="0" rIns="0" bIns="0" rtlCol="0" anchor="t"/>
+          <a:lstStyle/>
+          <a:p>
+            <a:pPr algn="l" indent="0" marL="0">
+              <a:lnSpc>
+                <a:spcPts val="1650"/>
+              </a:lnSpc>
+              <a:buNone/>
+            </a:pPr>
+            <a:r>
+              <a:rPr lang="ko-KR" altLang="en-US" sz="1100" spc="-11" kern="0" dirty="0">
+                <a:solidFill>
+                  <a:srgbClr val="737C8B"/>
+                </a:solidFill>
+                <a:latin typeface="Pretendard Medium" pitchFamily="34" charset="0"/>
+                <a:ea typeface="Pretendard Medium" pitchFamily="34" charset="-127"/>
+                <a:cs typeface="Pretendard Medium" pitchFamily="34" charset="-120"/>
+              </a:rPr>
+              <a:t>Automated BIM generation from inconsistent multi-view raster architectural drawings</a:t>
+            </a:r>
+            <a:br/>
+            <a:r>
+              <a:rPr lang="ko-KR" altLang="en-US" sz="1100" spc="-11" kern="0" dirty="0">
+                <a:solidFill>
+                  <a:srgbClr val="737C8B"/>
+                </a:solidFill>
+                <a:latin typeface="Pretendard Medium" pitchFamily="34" charset="0"/>
+                <a:ea typeface="Pretendard Medium" pitchFamily="34" charset="-127"/>
+                <a:cs typeface="Pretendard Medium" pitchFamily="34" charset="-120"/>
+              </a:rPr>
+              <a:t>with missing dimensions</a:t>
+            </a:r>
+            <a:endParaRPr lang="en-US" sz="1100" dirty="0"/>
+          </a:p>
+        </p:txBody>
+      </p:sp>
+      <p:sp>
+        <p:nvSpPr>
+          <p:cNvPr id="24" name="Automation in Construction · Vol. 187 · "/>
+          <p:cNvSpPr txBox="1"/>
+          <p:nvPr/>
+        </p:nvSpPr>
+        <p:spPr>
+          <a:xfrm>
+            <a:off x="882650" y="4144566"/>
+            <a:ext cx="2824180" cy="146050"/>
           </a:xfrm>
           <a:prstGeom prst="rect">
             <a:avLst/>
@@ -3345,7 +2507,7 @@
               <a:buNone/>
             </a:pPr>
             <a:r>
-              <a:rPr lang="ko-KR" altLang="en-US" sz="950" b="1" spc="-12" kern="0" dirty="0">
+              <a:rPr lang="ko-KR" altLang="en-US" sz="950" b="1" spc="-10" kern="0" dirty="0">
                 <a:solidFill>
                   <a:srgbClr val="102A4C"/>
                 </a:solidFill>
@@ -3353,38 +2515,10 @@
                 <a:ea typeface="Pretendard" pitchFamily="34" charset="-127"/>
                 <a:cs typeface="Pretendard" pitchFamily="34" charset="-120"/>
               </a:rPr>
-              <a:t>CONTENTS</a:t>
-            </a:r>
-            <a:endParaRPr lang="en-US" sz="950" dirty="0"/>
-          </a:p>
-        </p:txBody>
-      </p:sp>
-      <p:sp>
-        <p:nvSpPr>
-          <p:cNvPr id="43" name="발표 순서"/>
-          <p:cNvSpPr txBox="1"/>
-          <p:nvPr/>
-        </p:nvSpPr>
-        <p:spPr>
-          <a:xfrm>
-            <a:off x="1691184" y="401439"/>
-            <a:ext cx="488950" cy="146050"/>
-          </a:xfrm>
-          <a:prstGeom prst="rect">
-            <a:avLst/>
-          </a:prstGeom>
-          <a:noFill/>
-          <a:ln/>
-        </p:spPr>
-        <p:txBody>
-          <a:bodyPr wrap="none" lIns="0" tIns="0" rIns="0" bIns="0" rtlCol="0" anchor="ctr"/>
-          <a:lstStyle/>
-          <a:p>
-            <a:pPr algn="l" indent="0" marL="0">
-              <a:buNone/>
-            </a:pPr>
-            <a:r>
-              <a:rPr lang="ko-KR" altLang="en-US" sz="950" spc="-12" kern="0" dirty="0">
+              <a:t>Automation in Construction </a:t>
+            </a:r>
+            <a:r>
+              <a:rPr lang="ko-KR" altLang="en-US" sz="950" spc="-10" kern="0" dirty="0">
                 <a:solidFill>
                   <a:srgbClr val="737C8B"/>
                 </a:solidFill>
@@ -3392,38 +2526,21 @@
                 <a:ea typeface="Pretendard SemiBold" pitchFamily="34" charset="-127"/>
                 <a:cs typeface="Pretendard SemiBold" pitchFamily="34" charset="-120"/>
               </a:rPr>
-              <a:t>발표 순서</a:t>
-            </a:r>
-            <a:endParaRPr lang="en-US" sz="950" dirty="0"/>
-          </a:p>
-        </p:txBody>
-      </p:sp>
-      <p:sp>
-        <p:nvSpPr>
-          <p:cNvPr id="44" name="어떤 문제를, 어떻게 해결했고, 그게 SK하이닉스에서 왜 의미 있는가"/>
-          <p:cNvSpPr txBox="1"/>
-          <p:nvPr/>
-        </p:nvSpPr>
-        <p:spPr>
-          <a:xfrm>
-            <a:off x="609600" y="666750"/>
-            <a:ext cx="7605820" cy="349250"/>
-          </a:xfrm>
-          <a:prstGeom prst="rect">
-            <a:avLst/>
-          </a:prstGeom>
-          <a:noFill/>
-          <a:ln/>
-        </p:spPr>
-        <p:txBody>
-          <a:bodyPr wrap="none" lIns="0" tIns="0" rIns="0" bIns="0" rtlCol="0" anchor="ctr"/>
-          <a:lstStyle/>
-          <a:p>
-            <a:pPr algn="l" indent="0" marL="0">
-              <a:buNone/>
-            </a:pPr>
-            <a:r>
-              <a:rPr lang="ko-KR" altLang="en-US" sz="2300" spc="-92" kern="0" dirty="0">
+              <a:t>· Vol. 187 · 2026</a:t>
+            </a:r>
+            <a:r>
+              <a:rPr lang="ko-KR" altLang="en-US" sz="950" b="1" spc="-10" kern="0" dirty="0">
+                <a:solidFill>
+                  <a:srgbClr val="102A4C"/>
+                </a:solidFill>
+                <a:latin typeface="Pretendard" pitchFamily="34" charset="0"/>
+                <a:ea typeface="Pretendard" pitchFamily="34" charset="-127"/>
+                <a:cs typeface="Pretendard" pitchFamily="34" charset="-120"/>
+              </a:rPr>
+              <a:t> </a:t>
+            </a:r>
+            <a:r>
+              <a:rPr lang="ko-KR" altLang="en-US" sz="950" spc="-10" kern="0" dirty="0">
                 <a:solidFill>
                   <a:srgbClr val="102A4C"/>
                 </a:solidFill>
@@ -3431,33 +2548,334 @@
                 <a:ea typeface="Pretendard ExtraBold" pitchFamily="34" charset="-127"/>
                 <a:cs typeface="Pretendard ExtraBold" pitchFamily="34" charset="-120"/>
               </a:rPr>
-              <a:t>어떤 문제를, 어떻게 해결했고, </a:t>
-            </a:r>
-            <a:r>
-              <a:rPr lang="ko-KR" altLang="en-US" sz="2300" spc="-92" kern="0" dirty="0">
-                <a:solidFill>
-                  <a:srgbClr val="EA002C"/>
+              <a:t>게재</a:t>
+            </a:r>
+            <a:endParaRPr lang="en-US" sz="950" dirty="0"/>
+          </a:p>
+        </p:txBody>
+      </p:sp>
+      <p:sp>
+        <p:nvSpPr>
+          <p:cNvPr id="25" name="지원 직무"/>
+          <p:cNvSpPr txBox="1"/>
+          <p:nvPr/>
+        </p:nvSpPr>
+        <p:spPr>
+          <a:xfrm>
+            <a:off x="609600" y="5949355"/>
+            <a:ext cx="435670" cy="120650"/>
+          </a:xfrm>
+          <a:prstGeom prst="rect">
+            <a:avLst/>
+          </a:prstGeom>
+          <a:noFill/>
+          <a:ln/>
+        </p:spPr>
+        <p:txBody>
+          <a:bodyPr wrap="none" lIns="0" tIns="0" rIns="0" bIns="0" rtlCol="0" anchor="ctr"/>
+          <a:lstStyle/>
+          <a:p>
+            <a:pPr algn="l" indent="0" marL="0">
+              <a:buNone/>
+            </a:pPr>
+            <a:r>
+              <a:rPr lang="ko-KR" altLang="en-US" sz="800" b="1" spc="16" kern="0" dirty="0">
+                <a:solidFill>
+                  <a:srgbClr val="737C8B"/>
+                </a:solidFill>
+                <a:latin typeface="Pretendard" pitchFamily="34" charset="0"/>
+                <a:ea typeface="Pretendard" pitchFamily="34" charset="-127"/>
+                <a:cs typeface="Pretendard" pitchFamily="34" charset="-120"/>
+              </a:rPr>
+              <a:t>지원 직무</a:t>
+            </a:r>
+            <a:endParaRPr lang="en-US" sz="800" dirty="0"/>
+          </a:p>
+        </p:txBody>
+      </p:sp>
+      <p:sp>
+        <p:nvSpPr>
+          <p:cNvPr id="26" name="Utility 기술 (건축, BIM/5D)"/>
+          <p:cNvSpPr txBox="1"/>
+          <p:nvPr/>
+        </p:nvSpPr>
+        <p:spPr>
+          <a:xfrm>
+            <a:off x="609600" y="6134695"/>
+            <a:ext cx="1657719" cy="165100"/>
+          </a:xfrm>
+          <a:prstGeom prst="rect">
+            <a:avLst/>
+          </a:prstGeom>
+          <a:noFill/>
+          <a:ln/>
+        </p:spPr>
+        <p:txBody>
+          <a:bodyPr wrap="none" lIns="0" tIns="0" rIns="0" bIns="0" rtlCol="0" anchor="ctr"/>
+          <a:lstStyle/>
+          <a:p>
+            <a:pPr algn="l" indent="0" marL="0">
+              <a:buNone/>
+            </a:pPr>
+            <a:r>
+              <a:rPr lang="ko-KR" altLang="en-US" sz="1100" b="1" spc="-12" kern="0" dirty="0">
+                <a:solidFill>
+                  <a:srgbClr val="102A4C"/>
+                </a:solidFill>
+                <a:latin typeface="Pretendard" pitchFamily="34" charset="0"/>
+                <a:ea typeface="Pretendard" pitchFamily="34" charset="-127"/>
+                <a:cs typeface="Pretendard" pitchFamily="34" charset="-120"/>
+              </a:rPr>
+              <a:t>Utility 기술 (건축, BIM/5D)</a:t>
+            </a:r>
+            <a:endParaRPr lang="en-US" sz="1100" dirty="0"/>
+          </a:p>
+        </p:txBody>
+      </p:sp>
+      <p:sp>
+        <p:nvSpPr>
+          <p:cNvPr id="27" name="발표일"/>
+          <p:cNvSpPr txBox="1"/>
+          <p:nvPr/>
+        </p:nvSpPr>
+        <p:spPr>
+          <a:xfrm>
+            <a:off x="2687836" y="5949355"/>
+            <a:ext cx="320377" cy="120650"/>
+          </a:xfrm>
+          <a:prstGeom prst="rect">
+            <a:avLst/>
+          </a:prstGeom>
+          <a:noFill/>
+          <a:ln/>
+        </p:spPr>
+        <p:txBody>
+          <a:bodyPr wrap="none" lIns="0" tIns="0" rIns="0" bIns="0" rtlCol="0" anchor="ctr"/>
+          <a:lstStyle/>
+          <a:p>
+            <a:pPr algn="l" indent="0" marL="0">
+              <a:buNone/>
+            </a:pPr>
+            <a:r>
+              <a:rPr lang="ko-KR" altLang="en-US" sz="800" b="1" spc="16" kern="0" dirty="0">
+                <a:solidFill>
+                  <a:srgbClr val="737C8B"/>
+                </a:solidFill>
+                <a:latin typeface="Pretendard" pitchFamily="34" charset="0"/>
+                <a:ea typeface="Pretendard" pitchFamily="34" charset="-127"/>
+                <a:cs typeface="Pretendard" pitchFamily="34" charset="-120"/>
+              </a:rPr>
+              <a:t>발표일</a:t>
+            </a:r>
+            <a:endParaRPr lang="en-US" sz="800" dirty="0"/>
+          </a:p>
+        </p:txBody>
+      </p:sp>
+      <p:sp>
+        <p:nvSpPr>
+          <p:cNvPr id="28" name="2026. 12. 3."/>
+          <p:cNvSpPr txBox="1"/>
+          <p:nvPr/>
+        </p:nvSpPr>
+        <p:spPr>
+          <a:xfrm>
+            <a:off x="2687836" y="6134695"/>
+            <a:ext cx="855067" cy="165100"/>
+          </a:xfrm>
+          <a:prstGeom prst="rect">
+            <a:avLst/>
+          </a:prstGeom>
+          <a:noFill/>
+          <a:ln/>
+        </p:spPr>
+        <p:txBody>
+          <a:bodyPr wrap="none" lIns="0" tIns="0" rIns="0" bIns="0" rtlCol="0" anchor="ctr"/>
+          <a:lstStyle/>
+          <a:p>
+            <a:pPr algn="l" indent="0" marL="0">
+              <a:buNone/>
+            </a:pPr>
+            <a:r>
+              <a:rPr lang="ko-KR" altLang="en-US" sz="1100" b="1" spc="29" kern="0" dirty="0">
+                <a:solidFill>
+                  <a:srgbClr val="102A4C"/>
+                </a:solidFill>
+                <a:latin typeface="Pretendard" pitchFamily="34" charset="0"/>
+                <a:ea typeface="Pretendard" pitchFamily="34" charset="-127"/>
+                <a:cs typeface="Pretendard" pitchFamily="34" charset="-120"/>
+              </a:rPr>
+              <a:t>2026. 12. 3.</a:t>
+            </a:r>
+            <a:endParaRPr lang="en-US" sz="1100" dirty="0"/>
+          </a:p>
+        </p:txBody>
+      </p:sp>
+      <p:sp>
+        <p:nvSpPr>
+          <p:cNvPr id="29" name="지원자"/>
+          <p:cNvSpPr txBox="1"/>
+          <p:nvPr/>
+        </p:nvSpPr>
+        <p:spPr>
+          <a:xfrm>
+            <a:off x="4006453" y="5949355"/>
+            <a:ext cx="320377" cy="120650"/>
+          </a:xfrm>
+          <a:prstGeom prst="rect">
+            <a:avLst/>
+          </a:prstGeom>
+          <a:noFill/>
+          <a:ln/>
+        </p:spPr>
+        <p:txBody>
+          <a:bodyPr wrap="none" lIns="0" tIns="0" rIns="0" bIns="0" rtlCol="0" anchor="ctr"/>
+          <a:lstStyle/>
+          <a:p>
+            <a:pPr algn="l" indent="0" marL="0">
+              <a:buNone/>
+            </a:pPr>
+            <a:r>
+              <a:rPr lang="ko-KR" altLang="en-US" sz="800" b="1" spc="16" kern="0" dirty="0">
+                <a:solidFill>
+                  <a:srgbClr val="737C8B"/>
+                </a:solidFill>
+                <a:latin typeface="Pretendard" pitchFamily="34" charset="0"/>
+                <a:ea typeface="Pretendard" pitchFamily="34" charset="-127"/>
+                <a:cs typeface="Pretendard" pitchFamily="34" charset="-120"/>
+              </a:rPr>
+              <a:t>지원자</a:t>
+            </a:r>
+            <a:endParaRPr lang="en-US" sz="800" dirty="0"/>
+          </a:p>
+        </p:txBody>
+      </p:sp>
+      <p:sp>
+        <p:nvSpPr>
+          <p:cNvPr id="30" name="○○○"/>
+          <p:cNvSpPr txBox="1"/>
+          <p:nvPr/>
+        </p:nvSpPr>
+        <p:spPr>
+          <a:xfrm>
+            <a:off x="4006453" y="6134695"/>
+            <a:ext cx="421184" cy="165100"/>
+          </a:xfrm>
+          <a:prstGeom prst="rect">
+            <a:avLst/>
+          </a:prstGeom>
+          <a:noFill/>
+          <a:ln/>
+        </p:spPr>
+        <p:txBody>
+          <a:bodyPr wrap="none" lIns="0" tIns="0" rIns="0" bIns="0" rtlCol="0" anchor="ctr"/>
+          <a:lstStyle/>
+          <a:p>
+            <a:pPr algn="l" indent="0" marL="0">
+              <a:buNone/>
+            </a:pPr>
+            <a:r>
+              <a:rPr lang="ko-KR" altLang="en-US" sz="1100" b="1" spc="-12" kern="0" dirty="0">
+                <a:solidFill>
+                  <a:srgbClr val="102A4C"/>
+                </a:solidFill>
+                <a:latin typeface="Pretendard" pitchFamily="34" charset="0"/>
+                <a:ea typeface="Pretendard" pitchFamily="34" charset="-127"/>
+                <a:cs typeface="Pretendard" pitchFamily="34" charset="-120"/>
+              </a:rPr>
+              <a:t>○○○</a:t>
+            </a:r>
+            <a:endParaRPr lang="en-US" sz="1100" dirty="0"/>
+          </a:p>
+        </p:txBody>
+      </p:sp>
+      <p:sp>
+        <p:nvSpPr>
+          <p:cNvPr id="31" name="자동 생성"/>
+          <p:cNvSpPr txBox="1"/>
+          <p:nvPr/>
+        </p:nvSpPr>
+        <p:spPr>
+          <a:xfrm>
+            <a:off x="10154245" y="1590080"/>
+            <a:ext cx="417909" cy="120650"/>
+          </a:xfrm>
+          <a:prstGeom prst="rect">
+            <a:avLst/>
+          </a:prstGeom>
+          <a:noFill/>
+          <a:ln/>
+        </p:spPr>
+        <p:txBody>
+          <a:bodyPr wrap="none" lIns="0" tIns="0" rIns="0" bIns="0" rtlCol="0" anchor="ctr"/>
+          <a:lstStyle/>
+          <a:p>
+            <a:pPr algn="l" indent="0" marL="0">
+              <a:buNone/>
+            </a:pPr>
+            <a:r>
+              <a:rPr lang="ko-KR" altLang="en-US" sz="800" b="1" spc="-12" kern="0" dirty="0">
+                <a:solidFill>
+                  <a:srgbClr val="102A4C"/>
+                </a:solidFill>
+                <a:latin typeface="Pretendard" pitchFamily="34" charset="0"/>
+                <a:ea typeface="Pretendard" pitchFamily="34" charset="-127"/>
+                <a:cs typeface="Pretendard" pitchFamily="34" charset="-120"/>
+              </a:rPr>
+              <a:t>자동 생성</a:t>
+            </a:r>
+            <a:endParaRPr lang="en-US" sz="800" dirty="0"/>
+          </a:p>
+        </p:txBody>
+      </p:sp>
+      <p:sp>
+        <p:nvSpPr>
+          <p:cNvPr id="32" name="2D"/>
+          <p:cNvSpPr txBox="1"/>
+          <p:nvPr/>
+        </p:nvSpPr>
+        <p:spPr>
+          <a:xfrm>
+            <a:off x="7467600" y="2926358"/>
+            <a:ext cx="172145" cy="101600"/>
+          </a:xfrm>
+          <a:prstGeom prst="rect">
+            <a:avLst/>
+          </a:prstGeom>
+          <a:noFill/>
+          <a:ln/>
+        </p:spPr>
+        <p:txBody>
+          <a:bodyPr wrap="none" lIns="0" tIns="0" rIns="0" bIns="0" rtlCol="0" anchor="ctr"/>
+          <a:lstStyle/>
+          <a:p>
+            <a:pPr algn="l" indent="0" marL="0">
+              <a:buNone/>
+            </a:pPr>
+            <a:r>
+              <a:rPr lang="ko-KR" altLang="en-US" sz="700" spc="14" kern="0" dirty="0">
+                <a:solidFill>
+                  <a:srgbClr val="FFFFFF"/>
                 </a:solidFill>
                 <a:latin typeface="Pretendard ExtraBold" pitchFamily="34" charset="0"/>
                 <a:ea typeface="Pretendard ExtraBold" pitchFamily="34" charset="-127"/>
                 <a:cs typeface="Pretendard ExtraBold" pitchFamily="34" charset="-120"/>
               </a:rPr>
-              <a:t>그게 SK하이닉스에서 왜 의미 있는가</a:t>
-            </a:r>
-            <a:endParaRPr lang="en-US" sz="2300" dirty="0"/>
-          </a:p>
-        </p:txBody>
-      </p:sp>
-      <p:sp>
-        <p:nvSpPr>
-          <p:cNvPr id="45" name="문제"/>
-          <p:cNvSpPr txBox="1"/>
-          <p:nvPr/>
-        </p:nvSpPr>
-        <p:spPr>
-          <a:xfrm>
-            <a:off x="609600" y="1975545"/>
-            <a:ext cx="308173" cy="184150"/>
+              <a:t>2D</a:t>
+            </a:r>
+            <a:endParaRPr lang="en-US" sz="700" dirty="0"/>
+          </a:p>
+        </p:txBody>
+      </p:sp>
+      <p:sp>
+        <p:nvSpPr>
+          <p:cNvPr id="33" name="평면도 · 입면도 이미지"/>
+          <p:cNvSpPr txBox="1"/>
+          <p:nvPr/>
+        </p:nvSpPr>
+        <p:spPr>
+          <a:xfrm>
+            <a:off x="7703245" y="2917230"/>
+            <a:ext cx="922778" cy="120650"/>
           </a:xfrm>
           <a:prstGeom prst="rect">
             <a:avLst/>
@@ -3473,30 +2891,69 @@
               <a:buNone/>
             </a:pPr>
             <a:r>
-              <a:rPr lang="ko-KR" altLang="en-US" sz="1200" spc="-24" kern="0" dirty="0">
-                <a:solidFill>
-                  <a:srgbClr val="102A4C"/>
+              <a:rPr lang="ko-KR" altLang="en-US" sz="800" spc="-12" kern="0" dirty="0">
+                <a:solidFill>
+                  <a:srgbClr val="3F4654"/>
+                </a:solidFill>
+                <a:latin typeface="Pretendard SemiBold" pitchFamily="34" charset="0"/>
+                <a:ea typeface="Pretendard SemiBold" pitchFamily="34" charset="-127"/>
+                <a:cs typeface="Pretendard SemiBold" pitchFamily="34" charset="-120"/>
+              </a:rPr>
+              <a:t>평면도 · 입면도 이미지</a:t>
+            </a:r>
+            <a:endParaRPr lang="en-US" sz="800" dirty="0"/>
+          </a:p>
+        </p:txBody>
+      </p:sp>
+      <p:sp>
+        <p:nvSpPr>
+          <p:cNvPr id="34" name="3D"/>
+          <p:cNvSpPr txBox="1"/>
+          <p:nvPr/>
+        </p:nvSpPr>
+        <p:spPr>
+          <a:xfrm>
+            <a:off x="7467600" y="6139458"/>
+            <a:ext cx="174625" cy="101600"/>
+          </a:xfrm>
+          <a:prstGeom prst="rect">
+            <a:avLst/>
+          </a:prstGeom>
+          <a:noFill/>
+          <a:ln/>
+        </p:spPr>
+        <p:txBody>
+          <a:bodyPr wrap="none" lIns="0" tIns="0" rIns="0" bIns="0" rtlCol="0" anchor="ctr"/>
+          <a:lstStyle/>
+          <a:p>
+            <a:pPr algn="l" indent="0" marL="0">
+              <a:buNone/>
+            </a:pPr>
+            <a:r>
+              <a:rPr lang="ko-KR" altLang="en-US" sz="700" spc="14" kern="0" dirty="0">
+                <a:solidFill>
+                  <a:srgbClr val="FFFFFF"/>
                 </a:solidFill>
                 <a:latin typeface="Pretendard ExtraBold" pitchFamily="34" charset="0"/>
                 <a:ea typeface="Pretendard ExtraBold" pitchFamily="34" charset="-127"/>
                 <a:cs typeface="Pretendard ExtraBold" pitchFamily="34" charset="-120"/>
               </a:rPr>
-              <a:t>문제</a:t>
-            </a:r>
-            <a:endParaRPr lang="en-US" sz="1200" dirty="0"/>
-          </a:p>
-        </p:txBody>
-      </p:sp>
-      <p:sp>
-        <p:nvSpPr>
-          <p:cNvPr id="46" name="해결"/>
-          <p:cNvSpPr txBox="1"/>
-          <p:nvPr/>
-        </p:nvSpPr>
-        <p:spPr>
-          <a:xfrm>
-            <a:off x="5105400" y="1975545"/>
-            <a:ext cx="308173" cy="184150"/>
+              <a:t>3D</a:t>
+            </a:r>
+            <a:endParaRPr lang="en-US" sz="700" dirty="0"/>
+          </a:p>
+        </p:txBody>
+      </p:sp>
+      <p:sp>
+        <p:nvSpPr>
+          <p:cNvPr id="35" name="BIM 모델"/>
+          <p:cNvSpPr txBox="1"/>
+          <p:nvPr/>
+        </p:nvSpPr>
+        <p:spPr>
+          <a:xfrm>
+            <a:off x="7705725" y="6130330"/>
+            <a:ext cx="420390" cy="120650"/>
           </a:xfrm>
           <a:prstGeom prst="rect">
             <a:avLst/>
@@ -3512,178 +2969,7 @@
               <a:buNone/>
             </a:pPr>
             <a:r>
-              <a:rPr lang="ko-KR" altLang="en-US" sz="1200" spc="-24" kern="0" dirty="0">
-                <a:solidFill>
-                  <a:srgbClr val="102A4C"/>
-                </a:solidFill>
-                <a:latin typeface="Pretendard ExtraBold" pitchFamily="34" charset="0"/>
-                <a:ea typeface="Pretendard ExtraBold" pitchFamily="34" charset="-127"/>
-                <a:cs typeface="Pretendard ExtraBold" pitchFamily="34" charset="-120"/>
-              </a:rPr>
-              <a:t>해결</a:t>
-            </a:r>
-            <a:endParaRPr lang="en-US" sz="1200" dirty="0"/>
-          </a:p>
-        </p:txBody>
-      </p:sp>
-      <p:sp>
-        <p:nvSpPr>
-          <p:cNvPr id="47" name="의미"/>
-          <p:cNvSpPr txBox="1"/>
-          <p:nvPr/>
-        </p:nvSpPr>
-        <p:spPr>
-          <a:xfrm>
-            <a:off x="9601200" y="1975545"/>
-            <a:ext cx="308173" cy="184150"/>
-          </a:xfrm>
-          <a:prstGeom prst="rect">
-            <a:avLst/>
-          </a:prstGeom>
-          <a:noFill/>
-          <a:ln/>
-        </p:spPr>
-        <p:txBody>
-          <a:bodyPr wrap="none" lIns="0" tIns="0" rIns="0" bIns="0" rtlCol="0" anchor="ctr"/>
-          <a:lstStyle/>
-          <a:p>
-            <a:pPr algn="l" indent="0" marL="0">
-              <a:buNone/>
-            </a:pPr>
-            <a:r>
-              <a:rPr lang="ko-KR" altLang="en-US" sz="1200" spc="-24" kern="0" dirty="0">
-                <a:solidFill>
-                  <a:srgbClr val="102A4C"/>
-                </a:solidFill>
-                <a:latin typeface="Pretendard ExtraBold" pitchFamily="34" charset="0"/>
-                <a:ea typeface="Pretendard ExtraBold" pitchFamily="34" charset="-127"/>
-                <a:cs typeface="Pretendard ExtraBold" pitchFamily="34" charset="-120"/>
-              </a:rPr>
-              <a:t>의미</a:t>
-            </a:r>
-            <a:endParaRPr lang="en-US" sz="1200" dirty="0"/>
-          </a:p>
-        </p:txBody>
-      </p:sp>
-      <p:sp>
-        <p:nvSpPr>
-          <p:cNvPr id="48" name="01"/>
-          <p:cNvSpPr txBox="1"/>
-          <p:nvPr/>
-        </p:nvSpPr>
-        <p:spPr>
-          <a:xfrm>
-            <a:off x="812800" y="2619474"/>
-            <a:ext cx="569416" cy="482600"/>
-          </a:xfrm>
-          <a:prstGeom prst="rect">
-            <a:avLst/>
-          </a:prstGeom>
-          <a:noFill/>
-          <a:ln/>
-        </p:spPr>
-        <p:txBody>
-          <a:bodyPr wrap="none" lIns="0" tIns="0" rIns="0" bIns="0" rtlCol="0" anchor="ctr"/>
-          <a:lstStyle/>
-          <a:p>
-            <a:pPr algn="l" indent="0" marL="0">
-              <a:buNone/>
-            </a:pPr>
-            <a:r>
-              <a:rPr lang="ko-KR" altLang="en-US" sz="3200" spc="185" kern="0" dirty="0">
-                <a:solidFill>
-                  <a:srgbClr val="102A4C"/>
-                </a:solidFill>
-                <a:latin typeface="Pretendard ExtraBold" pitchFamily="34" charset="0"/>
-                <a:ea typeface="Pretendard ExtraBold" pitchFamily="34" charset="-127"/>
-                <a:cs typeface="Pretendard ExtraBold" pitchFamily="34" charset="-120"/>
-              </a:rPr>
-              <a:t>01</a:t>
-            </a:r>
-            <a:endParaRPr lang="en-US" sz="3200" dirty="0"/>
-          </a:p>
-        </p:txBody>
-      </p:sp>
-      <p:sp>
-        <p:nvSpPr>
-          <p:cNvPr id="49" name="연구 배경 및문제 정의"/>
-          <p:cNvSpPr txBox="1"/>
-          <p:nvPr/>
-        </p:nvSpPr>
-        <p:spPr>
-          <a:xfrm>
-            <a:off x="812800" y="3422154"/>
-            <a:ext cx="913523" cy="502841"/>
-          </a:xfrm>
-          <a:prstGeom prst="rect">
-            <a:avLst/>
-          </a:prstGeom>
-          <a:noFill/>
-          <a:ln/>
-        </p:spPr>
-        <p:txBody>
-          <a:bodyPr wrap="none" lIns="0" tIns="0" rIns="0" bIns="0" rtlCol="0" anchor="t"/>
-          <a:lstStyle/>
-          <a:p>
-            <a:pPr algn="l" indent="0" marL="0">
-              <a:lnSpc>
-                <a:spcPts val="1980"/>
-              </a:lnSpc>
-              <a:buNone/>
-            </a:pPr>
-            <a:r>
-              <a:rPr lang="ko-KR" altLang="en-US" sz="1500" spc="-53" kern="0" dirty="0">
-                <a:solidFill>
-                  <a:srgbClr val="102A4C"/>
-                </a:solidFill>
-                <a:latin typeface="Pretendard ExtraBold" pitchFamily="34" charset="0"/>
-                <a:ea typeface="Pretendard ExtraBold" pitchFamily="34" charset="-127"/>
-                <a:cs typeface="Pretendard ExtraBold" pitchFamily="34" charset="-120"/>
-              </a:rPr>
-              <a:t>연구 배경 및</a:t>
-            </a:r>
-            <a:br/>
-            <a:r>
-              <a:rPr lang="ko-KR" altLang="en-US" sz="1500" spc="-53" kern="0" dirty="0">
-                <a:solidFill>
-                  <a:srgbClr val="102A4C"/>
-                </a:solidFill>
-                <a:latin typeface="Pretendard ExtraBold" pitchFamily="34" charset="0"/>
-                <a:ea typeface="Pretendard ExtraBold" pitchFamily="34" charset="-127"/>
-                <a:cs typeface="Pretendard ExtraBold" pitchFamily="34" charset="-120"/>
-              </a:rPr>
-              <a:t>문제 정의</a:t>
-            </a:r>
-            <a:endParaRPr lang="en-US" sz="1500" dirty="0"/>
-          </a:p>
-        </p:txBody>
-      </p:sp>
-      <p:sp>
-        <p:nvSpPr>
-          <p:cNvPr id="50" name="왜 이 연구가 필요한가"/>
-          <p:cNvSpPr txBox="1"/>
-          <p:nvPr/>
-        </p:nvSpPr>
-        <p:spPr>
-          <a:xfrm>
-            <a:off x="812800" y="4626074"/>
-            <a:ext cx="1221782" cy="165100"/>
-          </a:xfrm>
-          <a:prstGeom prst="rect">
-            <a:avLst/>
-          </a:prstGeom>
-          <a:noFill/>
-          <a:ln/>
-        </p:spPr>
-        <p:txBody>
-          <a:bodyPr wrap="none" lIns="0" tIns="0" rIns="0" bIns="0" rtlCol="0" anchor="ctr"/>
-          <a:lstStyle/>
-          <a:p>
-            <a:pPr algn="l" indent="0" marL="0">
-              <a:buNone/>
-            </a:pPr>
-            <a:r>
-              <a:rPr lang="ko-KR" altLang="en-US" sz="1100" spc="-22" kern="0" dirty="0">
+              <a:rPr lang="ko-KR" altLang="en-US" sz="800" spc="-12" kern="0" dirty="0">
                 <a:solidFill>
                   <a:srgbClr val="3F4654"/>
                 </a:solidFill>
@@ -3691,653 +2977,9 @@
                 <a:ea typeface="Pretendard SemiBold" pitchFamily="34" charset="-127"/>
                 <a:cs typeface="Pretendard SemiBold" pitchFamily="34" charset="-120"/>
               </a:rPr>
-              <a:t>왜 이 연구가 필요한가</a:t>
-            </a:r>
-            <a:endParaRPr lang="en-US" sz="1100" dirty="0"/>
-          </a:p>
-        </p:txBody>
-      </p:sp>
-      <p:sp>
-        <p:nvSpPr>
-          <p:cNvPr id="51" name="02"/>
-          <p:cNvSpPr txBox="1"/>
-          <p:nvPr/>
-        </p:nvSpPr>
-        <p:spPr>
-          <a:xfrm>
-            <a:off x="2921000" y="2619474"/>
-            <a:ext cx="569416" cy="482600"/>
-          </a:xfrm>
-          <a:prstGeom prst="rect">
-            <a:avLst/>
-          </a:prstGeom>
-          <a:noFill/>
-          <a:ln/>
-        </p:spPr>
-        <p:txBody>
-          <a:bodyPr wrap="none" lIns="0" tIns="0" rIns="0" bIns="0" rtlCol="0" anchor="ctr"/>
-          <a:lstStyle/>
-          <a:p>
-            <a:pPr algn="l" indent="0" marL="0">
-              <a:buNone/>
-            </a:pPr>
-            <a:r>
-              <a:rPr lang="ko-KR" altLang="en-US" sz="3200" spc="-38" kern="0" dirty="0">
-                <a:solidFill>
-                  <a:srgbClr val="102A4C"/>
-                </a:solidFill>
-                <a:latin typeface="Pretendard ExtraBold" pitchFamily="34" charset="0"/>
-                <a:ea typeface="Pretendard ExtraBold" pitchFamily="34" charset="-127"/>
-                <a:cs typeface="Pretendard ExtraBold" pitchFamily="34" charset="-120"/>
-              </a:rPr>
-              <a:t>02</a:t>
-            </a:r>
-            <a:endParaRPr lang="en-US" sz="3200" dirty="0"/>
-          </a:p>
-        </p:txBody>
-      </p:sp>
-      <p:sp>
-        <p:nvSpPr>
-          <p:cNvPr id="52" name="기존 연구 한계 및연구 목표"/>
-          <p:cNvSpPr txBox="1"/>
-          <p:nvPr/>
-        </p:nvSpPr>
-        <p:spPr>
-          <a:xfrm>
-            <a:off x="2921000" y="3422154"/>
-            <a:ext cx="1286462" cy="502841"/>
-          </a:xfrm>
-          <a:prstGeom prst="rect">
-            <a:avLst/>
-          </a:prstGeom>
-          <a:noFill/>
-          <a:ln/>
-        </p:spPr>
-        <p:txBody>
-          <a:bodyPr wrap="none" lIns="0" tIns="0" rIns="0" bIns="0" rtlCol="0" anchor="t"/>
-          <a:lstStyle/>
-          <a:p>
-            <a:pPr algn="l" indent="0" marL="0">
-              <a:lnSpc>
-                <a:spcPts val="1980"/>
-              </a:lnSpc>
-              <a:buNone/>
-            </a:pPr>
-            <a:r>
-              <a:rPr lang="ko-KR" altLang="en-US" sz="1500" spc="-53" kern="0" dirty="0">
-                <a:solidFill>
-                  <a:srgbClr val="102A4C"/>
-                </a:solidFill>
-                <a:latin typeface="Pretendard ExtraBold" pitchFamily="34" charset="0"/>
-                <a:ea typeface="Pretendard ExtraBold" pitchFamily="34" charset="-127"/>
-                <a:cs typeface="Pretendard ExtraBold" pitchFamily="34" charset="-120"/>
-              </a:rPr>
-              <a:t>기존 연구 한계 및</a:t>
-            </a:r>
-            <a:br/>
-            <a:r>
-              <a:rPr lang="ko-KR" altLang="en-US" sz="1500" spc="-53" kern="0" dirty="0">
-                <a:solidFill>
-                  <a:srgbClr val="102A4C"/>
-                </a:solidFill>
-                <a:latin typeface="Pretendard ExtraBold" pitchFamily="34" charset="0"/>
-                <a:ea typeface="Pretendard ExtraBold" pitchFamily="34" charset="-127"/>
-                <a:cs typeface="Pretendard ExtraBold" pitchFamily="34" charset="-120"/>
-              </a:rPr>
-              <a:t>연구 목표</a:t>
-            </a:r>
-            <a:endParaRPr lang="en-US" sz="1500" dirty="0"/>
-          </a:p>
-        </p:txBody>
-      </p:sp>
-      <p:sp>
-        <p:nvSpPr>
-          <p:cNvPr id="53" name="기존 연구로는 왜 안 되는가,그래서 무엇을 목표로 했는가"/>
-          <p:cNvSpPr txBox="1"/>
-          <p:nvPr/>
-        </p:nvSpPr>
-        <p:spPr>
-          <a:xfrm>
-            <a:off x="2921000" y="4588669"/>
-            <a:ext cx="1596825" cy="405011"/>
-          </a:xfrm>
-          <a:prstGeom prst="rect">
-            <a:avLst/>
-          </a:prstGeom>
-          <a:noFill/>
-          <a:ln/>
-        </p:spPr>
-        <p:txBody>
-          <a:bodyPr wrap="none" lIns="0" tIns="0" rIns="0" bIns="0" rtlCol="0" anchor="t"/>
-          <a:lstStyle/>
-          <a:p>
-            <a:pPr algn="l" indent="0" marL="0">
-              <a:lnSpc>
-                <a:spcPts val="1595"/>
-              </a:lnSpc>
-              <a:buNone/>
-            </a:pPr>
-            <a:r>
-              <a:rPr lang="ko-KR" altLang="en-US" sz="1100" spc="-22" kern="0" dirty="0">
-                <a:solidFill>
-                  <a:srgbClr val="3F4654"/>
-                </a:solidFill>
-                <a:latin typeface="Pretendard SemiBold" pitchFamily="34" charset="0"/>
-                <a:ea typeface="Pretendard SemiBold" pitchFamily="34" charset="-127"/>
-                <a:cs typeface="Pretendard SemiBold" pitchFamily="34" charset="-120"/>
-              </a:rPr>
-              <a:t>기존 연구로는 왜 안 되는가,</a:t>
-            </a:r>
-            <a:br/>
-            <a:r>
-              <a:rPr lang="ko-KR" altLang="en-US" sz="1100" spc="-22" kern="0" dirty="0">
-                <a:solidFill>
-                  <a:srgbClr val="3F4654"/>
-                </a:solidFill>
-                <a:latin typeface="Pretendard SemiBold" pitchFamily="34" charset="0"/>
-                <a:ea typeface="Pretendard SemiBold" pitchFamily="34" charset="-127"/>
-                <a:cs typeface="Pretendard SemiBold" pitchFamily="34" charset="-120"/>
-              </a:rPr>
-              <a:t>그래서 무엇을 목표로 했는가</a:t>
-            </a:r>
-            <a:endParaRPr lang="en-US" sz="1100" dirty="0"/>
-          </a:p>
-        </p:txBody>
-      </p:sp>
-      <p:sp>
-        <p:nvSpPr>
-          <p:cNvPr id="54" name="03"/>
-          <p:cNvSpPr txBox="1"/>
-          <p:nvPr/>
-        </p:nvSpPr>
-        <p:spPr>
-          <a:xfrm>
-            <a:off x="5308600" y="2619474"/>
-            <a:ext cx="569416" cy="482600"/>
-          </a:xfrm>
-          <a:prstGeom prst="rect">
-            <a:avLst/>
-          </a:prstGeom>
-          <a:noFill/>
-          <a:ln/>
-        </p:spPr>
-        <p:txBody>
-          <a:bodyPr wrap="none" lIns="0" tIns="0" rIns="0" bIns="0" rtlCol="0" anchor="ctr"/>
-          <a:lstStyle/>
-          <a:p>
-            <a:pPr algn="l" indent="0" marL="0">
-              <a:buNone/>
-            </a:pPr>
-            <a:r>
-              <a:rPr lang="ko-KR" altLang="en-US" sz="3200" spc="-83" kern="0" dirty="0">
-                <a:solidFill>
-                  <a:srgbClr val="102A4C"/>
-                </a:solidFill>
-                <a:latin typeface="Pretendard ExtraBold" pitchFamily="34" charset="0"/>
-                <a:ea typeface="Pretendard ExtraBold" pitchFamily="34" charset="-127"/>
-                <a:cs typeface="Pretendard ExtraBold" pitchFamily="34" charset="-120"/>
-              </a:rPr>
-              <a:t>03</a:t>
-            </a:r>
-            <a:endParaRPr lang="en-US" sz="3200" dirty="0"/>
-          </a:p>
-        </p:txBody>
-      </p:sp>
-      <p:sp>
-        <p:nvSpPr>
-          <p:cNvPr id="55" name="연구 방법"/>
-          <p:cNvSpPr txBox="1"/>
-          <p:nvPr/>
-        </p:nvSpPr>
-        <p:spPr>
-          <a:xfrm>
-            <a:off x="5308600" y="3444974"/>
-            <a:ext cx="718641" cy="228600"/>
-          </a:xfrm>
-          <a:prstGeom prst="rect">
-            <a:avLst/>
-          </a:prstGeom>
-          <a:noFill/>
-          <a:ln/>
-        </p:spPr>
-        <p:txBody>
-          <a:bodyPr wrap="none" lIns="0" tIns="0" rIns="0" bIns="0" rtlCol="0" anchor="ctr"/>
-          <a:lstStyle/>
-          <a:p>
-            <a:pPr algn="l" indent="0" marL="0">
-              <a:buNone/>
-            </a:pPr>
-            <a:r>
-              <a:rPr lang="ko-KR" altLang="en-US" sz="1500" spc="-53" kern="0" dirty="0">
-                <a:solidFill>
-                  <a:srgbClr val="102A4C"/>
-                </a:solidFill>
-                <a:latin typeface="Pretendard ExtraBold" pitchFamily="34" charset="0"/>
-                <a:ea typeface="Pretendard ExtraBold" pitchFamily="34" charset="-127"/>
-                <a:cs typeface="Pretendard ExtraBold" pitchFamily="34" charset="-120"/>
-              </a:rPr>
-              <a:t>연구 방법</a:t>
-            </a:r>
-            <a:endParaRPr lang="en-US" sz="1500" dirty="0"/>
-          </a:p>
-        </p:txBody>
-      </p:sp>
-      <p:sp>
-        <p:nvSpPr>
-          <p:cNvPr id="56" name="어떻게 해결했는가"/>
-          <p:cNvSpPr txBox="1"/>
-          <p:nvPr/>
-        </p:nvSpPr>
-        <p:spPr>
-          <a:xfrm>
-            <a:off x="5308600" y="4626074"/>
-            <a:ext cx="1032367" cy="165100"/>
-          </a:xfrm>
-          <a:prstGeom prst="rect">
-            <a:avLst/>
-          </a:prstGeom>
-          <a:noFill/>
-          <a:ln/>
-        </p:spPr>
-        <p:txBody>
-          <a:bodyPr wrap="none" lIns="0" tIns="0" rIns="0" bIns="0" rtlCol="0" anchor="ctr"/>
-          <a:lstStyle/>
-          <a:p>
-            <a:pPr algn="l" indent="0" marL="0">
-              <a:buNone/>
-            </a:pPr>
-            <a:r>
-              <a:rPr lang="ko-KR" altLang="en-US" sz="1100" spc="-22" kern="0" dirty="0">
-                <a:solidFill>
-                  <a:srgbClr val="3F4654"/>
-                </a:solidFill>
-                <a:latin typeface="Pretendard SemiBold" pitchFamily="34" charset="0"/>
-                <a:ea typeface="Pretendard SemiBold" pitchFamily="34" charset="-127"/>
-                <a:cs typeface="Pretendard SemiBold" pitchFamily="34" charset="-120"/>
-              </a:rPr>
-              <a:t>어떻게 해결했는가</a:t>
-            </a:r>
-            <a:endParaRPr lang="en-US" sz="1100" dirty="0"/>
-          </a:p>
-        </p:txBody>
-      </p:sp>
-      <p:sp>
-        <p:nvSpPr>
-          <p:cNvPr id="57" name="04"/>
-          <p:cNvSpPr txBox="1"/>
-          <p:nvPr/>
-        </p:nvSpPr>
-        <p:spPr>
-          <a:xfrm>
-            <a:off x="7416800" y="2619474"/>
-            <a:ext cx="569416" cy="482600"/>
-          </a:xfrm>
-          <a:prstGeom prst="rect">
-            <a:avLst/>
-          </a:prstGeom>
-          <a:noFill/>
-          <a:ln/>
-        </p:spPr>
-        <p:txBody>
-          <a:bodyPr wrap="none" lIns="0" tIns="0" rIns="0" bIns="0" rtlCol="0" anchor="ctr"/>
-          <a:lstStyle/>
-          <a:p>
-            <a:pPr algn="l" indent="0" marL="0">
-              <a:buNone/>
-            </a:pPr>
-            <a:r>
-              <a:rPr lang="ko-KR" altLang="en-US" sz="3200" spc="-118" kern="0" dirty="0">
-                <a:solidFill>
-                  <a:srgbClr val="102A4C"/>
-                </a:solidFill>
-                <a:latin typeface="Pretendard ExtraBold" pitchFamily="34" charset="0"/>
-                <a:ea typeface="Pretendard ExtraBold" pitchFamily="34" charset="-127"/>
-                <a:cs typeface="Pretendard ExtraBold" pitchFamily="34" charset="-120"/>
-              </a:rPr>
-              <a:t>04</a:t>
-            </a:r>
-            <a:endParaRPr lang="en-US" sz="3200" dirty="0"/>
-          </a:p>
-        </p:txBody>
-      </p:sp>
-      <p:sp>
-        <p:nvSpPr>
-          <p:cNvPr id="58" name="연구 결과 및 기여"/>
-          <p:cNvSpPr txBox="1"/>
-          <p:nvPr/>
-        </p:nvSpPr>
-        <p:spPr>
-          <a:xfrm>
-            <a:off x="7416800" y="3444974"/>
-            <a:ext cx="1286462" cy="228600"/>
-          </a:xfrm>
-          <a:prstGeom prst="rect">
-            <a:avLst/>
-          </a:prstGeom>
-          <a:noFill/>
-          <a:ln/>
-        </p:spPr>
-        <p:txBody>
-          <a:bodyPr wrap="none" lIns="0" tIns="0" rIns="0" bIns="0" rtlCol="0" anchor="ctr"/>
-          <a:lstStyle/>
-          <a:p>
-            <a:pPr algn="l" indent="0" marL="0">
-              <a:buNone/>
-            </a:pPr>
-            <a:r>
-              <a:rPr lang="ko-KR" altLang="en-US" sz="1500" spc="-53" kern="0" dirty="0">
-                <a:solidFill>
-                  <a:srgbClr val="102A4C"/>
-                </a:solidFill>
-                <a:latin typeface="Pretendard ExtraBold" pitchFamily="34" charset="0"/>
-                <a:ea typeface="Pretendard ExtraBold" pitchFamily="34" charset="-127"/>
-                <a:cs typeface="Pretendard ExtraBold" pitchFamily="34" charset="-120"/>
-              </a:rPr>
-              <a:t>연구 결과 및 기여</a:t>
-            </a:r>
-            <a:endParaRPr lang="en-US" sz="1500" dirty="0"/>
-          </a:p>
-        </p:txBody>
-      </p:sp>
-      <p:sp>
-        <p:nvSpPr>
-          <p:cNvPr id="59" name="얼마나 잘 됐고,어떤 의미가 있는가"/>
-          <p:cNvSpPr txBox="1"/>
-          <p:nvPr/>
-        </p:nvSpPr>
-        <p:spPr>
-          <a:xfrm>
-            <a:off x="7416800" y="4588669"/>
-            <a:ext cx="1064550" cy="405011"/>
-          </a:xfrm>
-          <a:prstGeom prst="rect">
-            <a:avLst/>
-          </a:prstGeom>
-          <a:noFill/>
-          <a:ln/>
-        </p:spPr>
-        <p:txBody>
-          <a:bodyPr wrap="none" lIns="0" tIns="0" rIns="0" bIns="0" rtlCol="0" anchor="t"/>
-          <a:lstStyle/>
-          <a:p>
-            <a:pPr algn="l" indent="0" marL="0">
-              <a:lnSpc>
-                <a:spcPts val="1595"/>
-              </a:lnSpc>
-              <a:buNone/>
-            </a:pPr>
-            <a:r>
-              <a:rPr lang="ko-KR" altLang="en-US" sz="1100" spc="-22" kern="0" dirty="0">
-                <a:solidFill>
-                  <a:srgbClr val="3F4654"/>
-                </a:solidFill>
-                <a:latin typeface="Pretendard SemiBold" pitchFamily="34" charset="0"/>
-                <a:ea typeface="Pretendard SemiBold" pitchFamily="34" charset="-127"/>
-                <a:cs typeface="Pretendard SemiBold" pitchFamily="34" charset="-120"/>
-              </a:rPr>
-              <a:t>얼마나 잘 됐고,</a:t>
-            </a:r>
-            <a:br/>
-            <a:r>
-              <a:rPr lang="ko-KR" altLang="en-US" sz="1100" spc="-22" kern="0" dirty="0">
-                <a:solidFill>
-                  <a:srgbClr val="3F4654"/>
-                </a:solidFill>
-                <a:latin typeface="Pretendard SemiBold" pitchFamily="34" charset="0"/>
-                <a:ea typeface="Pretendard SemiBold" pitchFamily="34" charset="-127"/>
-                <a:cs typeface="Pretendard SemiBold" pitchFamily="34" charset="-120"/>
-              </a:rPr>
-              <a:t>어떤 의미가 있는가</a:t>
-            </a:r>
-            <a:endParaRPr lang="en-US" sz="1100" dirty="0"/>
-          </a:p>
-        </p:txBody>
-      </p:sp>
-      <p:sp>
-        <p:nvSpPr>
-          <p:cNvPr id="60" name="05"/>
-          <p:cNvSpPr txBox="1"/>
-          <p:nvPr/>
-        </p:nvSpPr>
-        <p:spPr>
-          <a:xfrm>
-            <a:off x="9804400" y="2619474"/>
-            <a:ext cx="569416" cy="482600"/>
-          </a:xfrm>
-          <a:prstGeom prst="rect">
-            <a:avLst/>
-          </a:prstGeom>
-          <a:noFill/>
-          <a:ln/>
-        </p:spPr>
-        <p:txBody>
-          <a:bodyPr wrap="none" lIns="0" tIns="0" rIns="0" bIns="0" rtlCol="0" anchor="ctr"/>
-          <a:lstStyle/>
-          <a:p>
-            <a:pPr algn="l" indent="0" marL="0">
-              <a:buNone/>
-            </a:pPr>
-            <a:r>
-              <a:rPr lang="ko-KR" altLang="en-US" sz="3200" spc="-69" kern="0" dirty="0">
-                <a:solidFill>
-                  <a:srgbClr val="FFFFFF"/>
-                </a:solidFill>
-                <a:latin typeface="Pretendard ExtraBold" pitchFamily="34" charset="0"/>
-                <a:ea typeface="Pretendard ExtraBold" pitchFamily="34" charset="-127"/>
-                <a:cs typeface="Pretendard ExtraBold" pitchFamily="34" charset="-120"/>
-              </a:rPr>
-              <a:t>05</a:t>
-            </a:r>
-            <a:endParaRPr lang="en-US" sz="3200" dirty="0"/>
-          </a:p>
-        </p:txBody>
-      </p:sp>
-      <p:sp>
-        <p:nvSpPr>
-          <p:cNvPr id="61" name="Utility 기술(건축, BIM/5D)직무와의 연관성"/>
-          <p:cNvSpPr txBox="1"/>
-          <p:nvPr/>
-        </p:nvSpPr>
-        <p:spPr>
-          <a:xfrm>
-            <a:off x="9804400" y="3422154"/>
-            <a:ext cx="1238820" cy="754261"/>
-          </a:xfrm>
-          <a:prstGeom prst="rect">
-            <a:avLst/>
-          </a:prstGeom>
-          <a:noFill/>
-          <a:ln/>
-        </p:spPr>
-        <p:txBody>
-          <a:bodyPr wrap="none" lIns="0" tIns="0" rIns="0" bIns="0" rtlCol="0" anchor="t"/>
-          <a:lstStyle/>
-          <a:p>
-            <a:pPr algn="l" indent="0" marL="0">
-              <a:lnSpc>
-                <a:spcPts val="1980"/>
-              </a:lnSpc>
-              <a:buNone/>
-            </a:pPr>
-            <a:r>
-              <a:rPr lang="ko-KR" altLang="en-US" sz="1500" spc="-53" kern="0" dirty="0">
-                <a:solidFill>
-                  <a:srgbClr val="FFFFFF"/>
-                </a:solidFill>
-                <a:latin typeface="Pretendard ExtraBold" pitchFamily="34" charset="0"/>
-                <a:ea typeface="Pretendard ExtraBold" pitchFamily="34" charset="-127"/>
-                <a:cs typeface="Pretendard ExtraBold" pitchFamily="34" charset="-120"/>
-              </a:rPr>
-              <a:t>Utility 기술</a:t>
-            </a:r>
-            <a:br/>
-            <a:r>
-              <a:rPr lang="ko-KR" altLang="en-US" sz="1500" spc="-53" kern="0" dirty="0">
-                <a:solidFill>
-                  <a:srgbClr val="FFFFFF"/>
-                </a:solidFill>
-                <a:latin typeface="Pretendard ExtraBold" pitchFamily="34" charset="0"/>
-                <a:ea typeface="Pretendard ExtraBold" pitchFamily="34" charset="-127"/>
-                <a:cs typeface="Pretendard ExtraBold" pitchFamily="34" charset="-120"/>
-              </a:rPr>
-              <a:t>(건축, BIM/5D)</a:t>
-            </a:r>
-            <a:br/>
-            <a:r>
-              <a:rPr lang="ko-KR" altLang="en-US" sz="1500" spc="-53" kern="0" dirty="0">
-                <a:solidFill>
-                  <a:srgbClr val="FFFFFF"/>
-                </a:solidFill>
-                <a:latin typeface="Pretendard ExtraBold" pitchFamily="34" charset="0"/>
-                <a:ea typeface="Pretendard ExtraBold" pitchFamily="34" charset="-127"/>
-                <a:cs typeface="Pretendard ExtraBold" pitchFamily="34" charset="-120"/>
-              </a:rPr>
-              <a:t>직무와의 연관성</a:t>
-            </a:r>
-            <a:endParaRPr lang="en-US" sz="1500" dirty="0"/>
-          </a:p>
-        </p:txBody>
-      </p:sp>
-      <p:sp>
-        <p:nvSpPr>
-          <p:cNvPr id="62" name="SK하이닉스 직무에서왜 중요한가"/>
-          <p:cNvSpPr txBox="1"/>
-          <p:nvPr/>
-        </p:nvSpPr>
-        <p:spPr>
-          <a:xfrm>
-            <a:off x="9804400" y="4588669"/>
-            <a:ext cx="1214735" cy="405011"/>
-          </a:xfrm>
-          <a:prstGeom prst="rect">
-            <a:avLst/>
-          </a:prstGeom>
-          <a:noFill/>
-          <a:ln/>
-        </p:spPr>
-        <p:txBody>
-          <a:bodyPr wrap="none" lIns="0" tIns="0" rIns="0" bIns="0" rtlCol="0" anchor="t"/>
-          <a:lstStyle/>
-          <a:p>
-            <a:pPr algn="l" indent="0" marL="0">
-              <a:lnSpc>
-                <a:spcPts val="1595"/>
-              </a:lnSpc>
-              <a:buNone/>
-            </a:pPr>
-            <a:r>
-              <a:rPr lang="ko-KR" altLang="en-US" sz="1100" spc="-22" kern="0" dirty="0">
-                <a:solidFill>
-                  <a:srgbClr val="E3E9F2"/>
-                </a:solidFill>
-                <a:latin typeface="Pretendard SemiBold" pitchFamily="34" charset="0"/>
-                <a:ea typeface="Pretendard SemiBold" pitchFamily="34" charset="-127"/>
-                <a:cs typeface="Pretendard SemiBold" pitchFamily="34" charset="-120"/>
-              </a:rPr>
-              <a:t>SK하이닉스 직무에서</a:t>
-            </a:r>
-            <a:br/>
-            <a:r>
-              <a:rPr lang="ko-KR" altLang="en-US" sz="1100" spc="-22" kern="0" dirty="0">
-                <a:solidFill>
-                  <a:srgbClr val="E3E9F2"/>
-                </a:solidFill>
-                <a:latin typeface="Pretendard SemiBold" pitchFamily="34" charset="0"/>
-                <a:ea typeface="Pretendard SemiBold" pitchFamily="34" charset="-127"/>
-                <a:cs typeface="Pretendard SemiBold" pitchFamily="34" charset="-120"/>
-              </a:rPr>
-              <a:t>왜 중요한가</a:t>
-            </a:r>
-            <a:endParaRPr lang="en-US" sz="1100" dirty="0"/>
-          </a:p>
-        </p:txBody>
-      </p:sp>
-      <p:sp>
-        <p:nvSpPr>
-          <p:cNvPr id="63" name="석사 연구 발표  ·  평면도와 입면도 객체 인식 및 정보 통합을 통한 "/>
-          <p:cNvSpPr txBox="1"/>
-          <p:nvPr/>
-        </p:nvSpPr>
-        <p:spPr>
-          <a:xfrm>
-            <a:off x="609600" y="6472238"/>
-            <a:ext cx="5145113" cy="114300"/>
-          </a:xfrm>
-          <a:prstGeom prst="rect">
-            <a:avLst/>
-          </a:prstGeom>
-          <a:noFill/>
-          <a:ln/>
-        </p:spPr>
-        <p:txBody>
-          <a:bodyPr wrap="none" lIns="0" tIns="0" rIns="0" bIns="0" rtlCol="0" anchor="ctr"/>
-          <a:lstStyle/>
-          <a:p>
-            <a:pPr algn="l" indent="0" marL="0">
-              <a:buNone/>
-            </a:pPr>
-            <a:r>
-              <a:rPr lang="ko-KR" altLang="en-US" sz="750" spc="-12" kern="0" dirty="0">
-                <a:solidFill>
-                  <a:srgbClr val="737C8B"/>
-                </a:solidFill>
-                <a:latin typeface="Pretendard Medium" pitchFamily="34" charset="0"/>
-                <a:ea typeface="Pretendard Medium" pitchFamily="34" charset="-127"/>
-                <a:cs typeface="Pretendard Medium" pitchFamily="34" charset="-120"/>
-              </a:rPr>
-              <a:t>석사 연구 발표  ·  평면도와 입면도 객체 인식 및 정보 통합을 통한 3D BIM 자동 생성 연구  ·  Utility 기술(건축, BIM/5D) 지원자 ○○○</a:t>
-            </a:r>
-            <a:endParaRPr lang="en-US" sz="750" dirty="0"/>
-          </a:p>
-        </p:txBody>
-      </p:sp>
-      <p:sp>
-        <p:nvSpPr>
-          <p:cNvPr id="64" name="01 / 10"/>
-          <p:cNvSpPr txBox="1"/>
-          <p:nvPr/>
-        </p:nvSpPr>
-        <p:spPr>
-          <a:xfrm>
-            <a:off x="11247934" y="6472238"/>
-            <a:ext cx="385266" cy="114300"/>
-          </a:xfrm>
-          <a:prstGeom prst="rect">
-            <a:avLst/>
-          </a:prstGeom>
-          <a:noFill/>
-          <a:ln/>
-        </p:spPr>
-        <p:txBody>
-          <a:bodyPr wrap="none" lIns="0" tIns="0" rIns="0" bIns="0" rtlCol="0" anchor="ctr"/>
-          <a:lstStyle/>
-          <a:p>
-            <a:pPr algn="l" indent="0" marL="0">
-              <a:buNone/>
-            </a:pPr>
-            <a:r>
-              <a:rPr lang="ko-KR" altLang="en-US" sz="750" spc="45" kern="0" dirty="0">
-                <a:solidFill>
-                  <a:srgbClr val="102A4C"/>
-                </a:solidFill>
-                <a:latin typeface="Pretendard ExtraBold" pitchFamily="34" charset="0"/>
-                <a:ea typeface="Pretendard ExtraBold" pitchFamily="34" charset="-127"/>
-                <a:cs typeface="Pretendard ExtraBold" pitchFamily="34" charset="-120"/>
-              </a:rPr>
-              <a:t>01</a:t>
-            </a:r>
-            <a:r>
-              <a:rPr lang="ko-KR" altLang="en-US" sz="750" spc="45" kern="0" dirty="0">
-                <a:solidFill>
-                  <a:srgbClr val="737C8B"/>
-                </a:solidFill>
-                <a:latin typeface="Pretendard SemiBold" pitchFamily="34" charset="0"/>
-                <a:ea typeface="Pretendard SemiBold" pitchFamily="34" charset="-127"/>
-                <a:cs typeface="Pretendard SemiBold" pitchFamily="34" charset="-120"/>
-              </a:rPr>
-              <a:t> / 10</a:t>
-            </a:r>
-            <a:endParaRPr lang="en-US" sz="750" dirty="0"/>
+              <a:t>BIM 모델</a:t>
+            </a:r>
+            <a:endParaRPr lang="en-US" sz="800" dirty="0"/>
           </a:p>
         </p:txBody>
       </p:sp>

</xml_diff>